<commit_message>
Align mid-term deck with the capstone plan's metadata
Course name, team name, week-based schedule (phase 1 this semester,
phase 2 next) and role split now follow the capstone application;
game content stays on the current v0.3 design. Adds the KISA smishing
figure cited in the plan and a speaker note on what changed from it.

Co-Authored-By: Claude Opus 5.5 <noreply@anthropic.com>
Claude-Session: https://claude.ai/code/session_016TK7RStkSbtFST378Masih
</commit_message>
<xml_diff>
--- a/docs/digital-guard/presentation/DIGITAL_GUARD_중간설계발표.pptx
+++ b/docs/digital-guard/presentation/DIGITAL_GUARD_중간설계발표.pptx
@@ -120,24 +120,24 @@
   <p:extLst>
     <p:ext uri="{521415D9-36F7-43E2-AB2F-B90AF26B5E84}">
       <p14:sectionLst xmlns:p14="http://schemas.microsoft.com/office/powerpoint/2010/main">
-        <p14:section name="표지" id="{0b505d2c-c5f6-34d7-27ab-ab815c27f904}">
+        <p14:section name="표지" id="{64a6a486-66de-3513-c182-dd88d9235a62}">
           <p14:sldIdLst>
             <p14:sldId id="256"/>
           </p14:sldIdLst>
         </p14:section>
-        <p14:section name="01 게임 소개" id="{39602eb3-b621-75ee-f1be-25e7d05c24b1}">
+        <p14:section name="01 게임 소개" id="{97374177-f983-099c-b17c-07588c42b8b9}">
           <p14:sldIdLst>
             <p14:sldId id="257"/>
             <p14:sldId id="258"/>
             <p14:sldId id="259"/>
           </p14:sldIdLst>
         </p14:section>
-        <p14:section name="02 핵심 기능" id="{61d51c8c-dece-bf6d-db2a-2737d8ac2b81}">
+        <p14:section name="02 핵심 기능" id="{d05fb2b0-8baf-02ba-aa7d-830c23dbf50a}">
           <p14:sldIdLst>
             <p14:sldId id="260"/>
           </p14:sldIdLst>
         </p14:section>
-        <p14:section name="03 화면 설계" id="{be056565-ff6b-f593-1bcb-12211451633e}">
+        <p14:section name="03 화면 설계" id="{8b54013c-aeed-8a27-a9f0-55cedd3c98d1}">
           <p14:sldIdLst>
             <p14:sldId id="261"/>
             <p14:sldId id="262"/>
@@ -147,13 +147,13 @@
             <p14:sldId id="266"/>
           </p14:sldIdLst>
         </p14:section>
-        <p14:section name="04 점검 · 계획" id="{d8b1fbe8-086f-6833-8390-8410fa89a261}">
+        <p14:section name="04 점검 · 계획" id="{ed7d5865-897a-e8fe-85f2-810fa395d303}">
           <p14:sldIdLst>
             <p14:sldId id="267"/>
             <p14:sldId id="268"/>
           </p14:sldIdLst>
         </p14:section>
-        <p14:section name="마무리" id="{b15e84e9-53e9-0f5f-75ee-474cca78b7d5}">
+        <p14:section name="마무리" id="{e97e6fa0-a0f4-fdb5-2484-a0999fdec1c4}">
           <p14:sldIdLst>
             <p14:sldId id="269"/>
           </p14:sldIdLst>
@@ -562,7 +562,7 @@
           <a:p>
             <a:r>
               <a:rPr lang="en-US" dirty="0"/>
-              <a:t>안녕하세요, 팀 ○○입니다. 저희는 수상한 문자·파일·로그인 요청을 서류처럼 대조해서 가려내는 전연령 디지털 안전 퍼즐 게임, DIGITAL GUARD를 기획하고 있습니다. 이름은 아직 가칭입니다. 오늘은 무엇을 만드는지, 그리고 어떤 화면으로 동작하는지를 중심으로 말씀드리겠습니다.</a:t>
+              <a:t>안녕하세요, 팀 셜록홈즈입니다. 저희는 수상한 문자·파일·로그인 요청을 서류처럼 대조해서 가려내는 전연령 디지털 안전 퍼즐 게임, DIGITAL GUARD를 기획하고 있습니다. 이름은 아직 가칭입니다. 오늘은 무엇을 만드는지, 그리고 어떤 화면으로 동작하는지를 중심으로 말씀드리겠습니다.</a:t>
             </a:r>
             <a:endParaRPr lang="en-US" dirty="0"/>
           </a:p>
@@ -826,7 +826,7 @@
           <a:p>
             <a:r>
               <a:rPr lang="en-US" dirty="0"/>
-              <a:t>지금까지 보여 드린 기능을 표로 점검했습니다. 꼭 만들 기능 다섯 개는 HTML 시제품에서 하루치 흐름이 동작하는 것까지 확인했습니다. 보안 사전과 복습 노트, 밝은 모던 테마, 센터 꾸미기는 시간이 남으면 추가합니다. 광고와 결제, 온라인 순위와 계정, 실제 기관이나 인물 자료는 이번 프로젝트에서 만들지 않습니다.</a:t>
+              <a:t>지금까지 보여 드린 기능을 표로 점검했습니다. 꼭 만들 기능 다섯 개는 HTML 시제품에서 하루치 흐름이 동작하는 것까지 확인했습니다. 보안 사전과 복습 노트, 밝은 모던 테마, 센터 꾸미기는 시간이 남으면 추가합니다. 광고와 결제, 온라인 순위와 계정, 실제 기관이나 인물 자료는 이번 프로젝트에서 만들지 않습니다. 과제 계획서에서는 서버 계정과 랭킹을 계획했지만, 어린이와 어르신이 함께 쓰는 교육용 게임이라 개인정보를 받지 않는 오프라인 방식으로 바꾸고, 진행은 기기 안에 저장하기로 했습니다.</a:t>
             </a:r>
             <a:endParaRPr lang="en-US" dirty="0"/>
           </a:p>
@@ -914,7 +914,7 @@
           <a:p>
             <a:r>
               <a:rPr lang="en-US" dirty="0"/>
-              <a:t>기말까지는 사례 14개를 다듬고, 여러 세대에게 HTML 시제품을 직접 해 보게 해서 문장 난이도와 조작을 확인하겠습니다. 12월 기말발표에서 기능과 화면을 확정하고, 다음 학기에는 Unity로 화면 틀과 사례 데이터 불러오기, 판정 엔진과 Day 0~4 순서로 만들겠습니다. 5월에 여러 세대 10명에게 직접 해 보게 한 뒤 6월에 시연하겠습니다. 역할은 사례 작성, Unity 개발, 도트 그래픽, 테스트와 접근성으로 나눕니다.</a:t>
+              <a:t>일정은 과제 계획서의 주차 계획을 따릅니다. 9월에 주제를 정하고 유사 콘텐츠를 조사했고, 지금은 게임 흐름과 화면을 설계해 HTML 시제품까지 만든 상태입니다. 8~10주에는 보안 수칙과 사례 규칙, 저장 데이터를 정리하고, 11~13주에 판정 엔진과 하루치 사례가 동작하는 Unity 프로토타입을 만든 뒤, 14~15주에 테스트와 산출물을 정리해 기말발표를 하겠습니다. 다음 학기 2단계에서 전체 기능과 사례를 채우고 최종 발표를 합니다. 팀원 네 명이 모두 기획에 참여하고, 메인 개발, 디자인과 사례 개발, 보고서를 나눠 맡습니다.</a:t>
             </a:r>
             <a:endParaRPr lang="en-US" dirty="0"/>
           </a:p>
@@ -1002,7 +1002,7 @@
           <a:p>
             <a:r>
               <a:rPr lang="en-US" dirty="0"/>
-              <a:t>마지막으로 저희가 걱정하는 세 가지입니다. 어린이부터 어르신까지 한 게임으로 괜찮을지, 정답을 근무가 끝난 뒤에 알려 주면 답답하지 않을지, 그리고 사례 14개와 화면 10개를 다음 학기에 다 만들 수 있을지입니다. 의견 주시면 기말까지 반영하겠습니다. 감사합니다.</a:t>
+              <a:t>마지막으로 저희가 걱정하는 세 가지입니다. 어린이부터 어르신까지 한 게임으로 괜찮을지, 정답을 근무가 끝난 뒤에 알려 주면 답답하지 않을지, 그리고 이번 학기 안에 Unity 프로토타입까지 갈 수 있을지입니다. 의견 주시면 기말까지 반영하겠습니다. 감사합니다.</a:t>
             </a:r>
             <a:endParaRPr lang="en-US" dirty="0"/>
           </a:p>
@@ -1090,7 +1090,7 @@
           <a:p>
             <a:r>
               <a:rPr lang="en-US" dirty="0"/>
-              <a:t>DIGITAL GUARD를 한 문장으로 말하면, 수상한 문자나 파일, 로그인 요청을 내 기록이나 공식 자료와 대조해서 승인할지, 거부할지, 추가로 확인할지를 판정하는 전연령 퍼즐 게임입니다. 스마트폰을 쓰는 누구나 대상이고, 하루 한 판은 10~15분 정도입니다. 조심하라는 말은 많이 듣지만, 직접 비교해 보는 연습을 할 곳은 많지 않다는 점에서 출발했습니다.</a:t>
+              <a:t>DIGITAL GUARD를 한 문장으로 말하면, 수상한 문자나 파일, 로그인 요청을 내 기록이나 공식 자료와 대조해서 승인할지, 거부할지, 추가로 확인할지를 판정하는 전연령 퍼즐 게임입니다. 스마트폰을 쓰는 누구나 대상이고, 하루 한 판은 10~15분 정도입니다. 지금의 보안 교육은 강의나 포스터 위주라서, 실제 상황에서 직접 비교하고 판단해 보는 경험으로 이어지기 어렵다는 점에서 출발했습니다.</a:t>
             </a:r>
             <a:endParaRPr lang="en-US" dirty="0"/>
           </a:p>
@@ -1178,7 +1178,7 @@
           <a:p>
             <a:r>
               <a:rPr lang="en-US" dirty="0"/>
-              <a:t>회사원 하늘 씨의 점심시간을 예로 들어 보겠습니다. 주소 불명 택배 문자를 받고, 바빠서 링크부터 누른 뒤 이름과 주소를 입력했습니다. 저녁에 쇼핑 앱을 보니 기다리는 택배가 없었습니다. 링크 주소와 공식 주소, 그리고 내 주문 내역. 이 두 가지만 비교했어도 알아챌 수 있었습니다. 문제는 이런 비교 습관을 미리 연습할 곳이 없다는 점이고, 이 장면은 실제로 게임의 첫 사건이 됩니다.</a:t>
+              <a:t>회사원 하늘 씨의 점심시간을 예로 들어 보겠습니다. 주소 불명 택배 문자를 받고, 바빠서 링크부터 누른 뒤 이름과 주소를 입력했습니다. 저녁에 쇼핑 앱을 보니 기다리는 택배가 없었습니다. 링크 주소와 공식 주소, 그리고 내 주문 내역. 이 두 가지만 비교했어도 알아챌 수 있었습니다. 문제는 이런 비교 습관을 미리 연습할 곳이 없다는 점이고, 이 장면은 실제로 게임의 첫 사건이 됩니다. 한국인터넷진흥원 자료에 따르면 스미싱 문자 탐지 건수는 2022년 3만 7천여 건에서 2024년 219만 건으로 늘었습니다.</a:t>
             </a:r>
             <a:endParaRPr lang="en-US" dirty="0"/>
           </a:p>
@@ -1874,7 +1874,7 @@
                 <a:ea typeface="Galmuri11" pitchFamily="34" charset="-122"/>
                 <a:cs typeface="Galmuri11" pitchFamily="34" charset="-120"/>
               </a:rPr>
-              <a:t>DIGITAL GUARD (가칭)  |  중간 설계발표  |  ※ 게임 속 인물·기관·자료는 모두 가상입니다</a:t>
+              <a:t>DIGITAL GUARD (가칭)  |  소프트웨어창의설계1 중간 설계발표  |  팀 셜록홈즈  |  ※ 게임 속 인물·기관·자료는 모두 가상</a:t>
             </a:r>
             <a:endParaRPr lang="en-US" sz="1000" dirty="0"/>
           </a:p>
@@ -2355,7 +2355,7 @@
         <p:spPr>
           <a:xfrm>
             <a:off x="685800" y="868680"/>
-            <a:ext cx="2743200" cy="365760"/>
+            <a:ext cx="4846320" cy="365760"/>
           </a:xfrm>
           <a:prstGeom prst="rect">
             <a:avLst/>
@@ -2375,7 +2375,7 @@
         <p:spPr>
           <a:xfrm>
             <a:off x="736092" y="918972"/>
-            <a:ext cx="2642616" cy="265176"/>
+            <a:ext cx="4745736" cy="265176"/>
           </a:xfrm>
           <a:prstGeom prst="rect">
             <a:avLst/>
@@ -2414,7 +2414,7 @@
         </p:nvSpPr>
         <p:spPr>
           <a:xfrm>
-            <a:off x="3378708" y="868680"/>
+            <a:off x="5481828" y="868680"/>
             <a:ext cx="50292" cy="50292"/>
           </a:xfrm>
           <a:prstGeom prst="rect">
@@ -2454,7 +2454,7 @@
         </p:nvSpPr>
         <p:spPr>
           <a:xfrm>
-            <a:off x="3378708" y="1184148"/>
+            <a:off x="5481828" y="1184148"/>
             <a:ext cx="50292" cy="50292"/>
           </a:xfrm>
           <a:prstGeom prst="rect">
@@ -2475,7 +2475,7 @@
         <p:spPr>
           <a:xfrm>
             <a:off x="685800" y="868680"/>
-            <a:ext cx="2743200" cy="365760"/>
+            <a:ext cx="4846320" cy="365760"/>
           </a:xfrm>
           <a:prstGeom prst="rect">
             <a:avLst/>
@@ -2499,7 +2499,7 @@
                 <a:ea typeface="Galmuri11" pitchFamily="34" charset="-122"/>
                 <a:cs typeface="Galmuri11" pitchFamily="34" charset="-120"/>
               </a:rPr>
-              <a:t>[과목명]  ·  중간 설계발표</a:t>
+              <a:t>소프트웨어창의설계1 (캡스톤디자인)  ·  중간 설계발표</a:t>
             </a:r>
             <a:endParaRPr lang="ko-KR" sz="1300" dirty="0"/>
           </a:p>
@@ -2954,7 +2954,7 @@
                 <a:ea typeface="Galmuri11" pitchFamily="34" charset="-122"/>
                 <a:cs typeface="Galmuri11" pitchFamily="34" charset="-120"/>
               </a:rPr>
-              <a:t>Team ________  |  ________ · ________</a:t>
+              <a:t>Team 셜록홈즈  |  ○○○·○○○·○○○·○○○</a:t>
             </a:r>
             <a:endParaRPr lang="ko-KR" sz="1300" dirty="0"/>
           </a:p>
@@ -10534,7 +10534,7 @@
                           <a:ea typeface="Galmuri11" pitchFamily="34" charset="-122"/>
                           <a:cs typeface="Galmuri11" pitchFamily="34" charset="-120"/>
                         </a:rPr>
-                        <a:t>다음 학기</a:t>
+                        <a:t>우선순위</a:t>
                       </a:r>
                       <a:endParaRPr lang="en-US" sz="1200" dirty="0">
                         <a:latin typeface="Galmuri11" charset="0"/>
@@ -14292,7 +14292,7 @@
                 <a:ea typeface="Galmuri14" pitchFamily="34" charset="-122"/>
                 <a:cs typeface="Galmuri14" pitchFamily="34" charset="-120"/>
               </a:rPr>
-              <a:t>앞으로 이렇게 만들어요 (계획안)</a:t>
+              <a:t>앞으로 이렇게 만들어요</a:t>
             </a:r>
             <a:endParaRPr lang="en-US" sz="2800" dirty="0"/>
           </a:p>
@@ -14307,7 +14307,7 @@
         <p:spPr>
           <a:xfrm>
             <a:off x="548640" y="1554480"/>
-            <a:ext cx="4526280" cy="365760"/>
+            <a:ext cx="8732520" cy="365760"/>
           </a:xfrm>
           <a:prstGeom prst="rect">
             <a:avLst/>
@@ -14327,7 +14327,7 @@
         <p:spPr>
           <a:xfrm>
             <a:off x="598932" y="1604772"/>
-            <a:ext cx="4425696" cy="265176"/>
+            <a:ext cx="8631936" cy="265176"/>
           </a:xfrm>
           <a:prstGeom prst="rect">
             <a:avLst/>
@@ -14366,7 +14366,7 @@
         </p:nvSpPr>
         <p:spPr>
           <a:xfrm>
-            <a:off x="5024628" y="1554480"/>
+            <a:off x="9230868" y="1554480"/>
             <a:ext cx="50292" cy="50292"/>
           </a:xfrm>
           <a:prstGeom prst="rect">
@@ -14406,7 +14406,7 @@
         </p:nvSpPr>
         <p:spPr>
           <a:xfrm>
-            <a:off x="5024628" y="1869948"/>
+            <a:off x="9230868" y="1869948"/>
             <a:ext cx="50292" cy="50292"/>
           </a:xfrm>
           <a:prstGeom prst="rect">
@@ -14427,7 +14427,7 @@
         <p:spPr>
           <a:xfrm>
             <a:off x="548640" y="1554480"/>
-            <a:ext cx="4526280" cy="365760"/>
+            <a:ext cx="8732520" cy="365760"/>
           </a:xfrm>
           <a:prstGeom prst="rect">
             <a:avLst/>
@@ -14451,7 +14451,7 @@
                 <a:ea typeface="Galmuri11" pitchFamily="34" charset="-122"/>
                 <a:cs typeface="Galmuri11" pitchFamily="34" charset="-120"/>
               </a:rPr>
-              <a:t>이번 학기 · 설계</a:t>
+              <a:t>1단계 · 이번 학기 (설계 · 프로토타입)</a:t>
             </a:r>
             <a:endParaRPr lang="ko-KR" sz="1300" dirty="0"/>
           </a:p>
@@ -14465,8 +14465,8 @@
         </p:nvSpPr>
         <p:spPr>
           <a:xfrm>
-            <a:off x="5257800" y="1554480"/>
-            <a:ext cx="6382512" cy="365760"/>
+            <a:off x="9464040" y="1554480"/>
+            <a:ext cx="2176272" cy="365760"/>
           </a:xfrm>
           <a:prstGeom prst="rect">
             <a:avLst/>
@@ -14485,8 +14485,8 @@
         </p:nvSpPr>
         <p:spPr>
           <a:xfrm>
-            <a:off x="5308092" y="1604772"/>
-            <a:ext cx="6281928" cy="265176"/>
+            <a:off x="9514332" y="1604772"/>
+            <a:ext cx="2075688" cy="265176"/>
           </a:xfrm>
           <a:prstGeom prst="rect">
             <a:avLst/>
@@ -14505,7 +14505,7 @@
         </p:nvSpPr>
         <p:spPr>
           <a:xfrm>
-            <a:off x="5257800" y="1554480"/>
+            <a:off x="9464040" y="1554480"/>
             <a:ext cx="50292" cy="50292"/>
           </a:xfrm>
           <a:prstGeom prst="rect">
@@ -14545,7 +14545,7 @@
         </p:nvSpPr>
         <p:spPr>
           <a:xfrm>
-            <a:off x="5257800" y="1869948"/>
+            <a:off x="9464040" y="1869948"/>
             <a:ext cx="50292" cy="50292"/>
           </a:xfrm>
           <a:prstGeom prst="rect">
@@ -14585,8 +14585,8 @@
         </p:nvSpPr>
         <p:spPr>
           <a:xfrm>
-            <a:off x="5257800" y="1554480"/>
-            <a:ext cx="6382512" cy="365760"/>
+            <a:off x="9464040" y="1554480"/>
+            <a:ext cx="2176272" cy="365760"/>
           </a:xfrm>
           <a:prstGeom prst="rect">
             <a:avLst/>
@@ -14610,7 +14610,7 @@
                 <a:ea typeface="Galmuri11" pitchFamily="34" charset="-122"/>
                 <a:cs typeface="Galmuri11" pitchFamily="34" charset="-120"/>
               </a:rPr>
-              <a:t>다음 학기 · 개발</a:t>
+              <a:t>2단계 · 다음 학기</a:t>
             </a:r>
             <a:endParaRPr lang="ko-KR" sz="1300" dirty="0"/>
           </a:p>
@@ -14644,7 +14644,7 @@
         </p:nvSpPr>
         <p:spPr>
           <a:xfrm>
-            <a:off x="320040" y="2029968"/>
+            <a:off x="457200" y="2029968"/>
             <a:ext cx="1645920" cy="292608"/>
           </a:xfrm>
           <a:prstGeom prst="rect">
@@ -14663,13 +14663,13 @@
             <a:r>
               <a:rPr lang="ko-KR" altLang="en-US" sz="1300" b="1" dirty="0">
                 <a:solidFill>
-                  <a:srgbClr val="F7D84A"/>
+                  <a:srgbClr val="FFFFFF"/>
                 </a:solidFill>
                 <a:latin typeface="Galmuri11" pitchFamily="34" charset="0"/>
                 <a:ea typeface="Galmuri11" pitchFamily="34" charset="-122"/>
                 <a:cs typeface="Galmuri11" pitchFamily="34" charset="-120"/>
               </a:rPr>
-              <a:t>10월 · 현재</a:t>
+              <a:t>1~4주 · 9월</a:t>
             </a:r>
             <a:endParaRPr lang="ko-KR" sz="1300" dirty="0"/>
           </a:p>
@@ -14683,14 +14683,14 @@
         </p:nvSpPr>
         <p:spPr>
           <a:xfrm>
-            <a:off x="1005840" y="2478024"/>
-            <a:ext cx="274320" cy="274320"/>
-          </a:xfrm>
-          <a:prstGeom prst="rect">
-            <a:avLst/>
-          </a:prstGeom>
-          <a:solidFill>
-            <a:srgbClr val="F7D84A"/>
+            <a:off x="1188720" y="2523744"/>
+            <a:ext cx="182880" cy="182880"/>
+          </a:xfrm>
+          <a:prstGeom prst="rect">
+            <a:avLst/>
+          </a:prstGeom>
+          <a:solidFill>
+            <a:srgbClr val="3FBF6F"/>
           </a:solidFill>
           <a:ln/>
         </p:spPr>
@@ -14703,8 +14703,8 @@
         </p:nvSpPr>
         <p:spPr>
           <a:xfrm>
-            <a:off x="365760" y="2834640"/>
-            <a:ext cx="1554480" cy="640080"/>
+            <a:off x="429768" y="2834640"/>
+            <a:ext cx="1700784" cy="731520"/>
           </a:xfrm>
           <a:prstGeom prst="rect">
             <a:avLst/>
@@ -14731,7 +14731,7 @@
                 <a:ea typeface="맑은 고딕" pitchFamily="34" charset="-122"/>
                 <a:cs typeface="맑은 고딕" pitchFamily="34" charset="-120"/>
               </a:rPr>
-              <a:t>중간발표</a:t>
+              <a:t>주제 확정</a:t>
             </a:r>
             <a:endParaRPr lang="ko-KR" sz="1100" dirty="0"/>
           </a:p>
@@ -14751,7 +14751,7 @@
                 <a:ea typeface="맑은 고딕" pitchFamily="34" charset="-122"/>
                 <a:cs typeface="맑은 고딕" pitchFamily="34" charset="-120"/>
               </a:rPr>
-              <a:t>기획서·HTML 시제품</a:t>
+              <a:t>유사 콘텐츠 조사</a:t>
             </a:r>
             <a:endParaRPr lang="ko-KR" sz="1100" dirty="0"/>
           </a:p>
@@ -14765,7 +14765,7 @@
         </p:nvSpPr>
         <p:spPr>
           <a:xfrm>
-            <a:off x="1874520" y="2029968"/>
+            <a:off x="2194560" y="2029968"/>
             <a:ext cx="1645920" cy="292608"/>
           </a:xfrm>
           <a:prstGeom prst="rect">
@@ -14784,13 +14784,13 @@
             <a:r>
               <a:rPr lang="ko-KR" altLang="en-US" sz="1300" b="1" dirty="0">
                 <a:solidFill>
-                  <a:srgbClr val="FFFFFF"/>
+                  <a:srgbClr val="F7D84A"/>
                 </a:solidFill>
                 <a:latin typeface="Galmuri11" pitchFamily="34" charset="0"/>
                 <a:ea typeface="Galmuri11" pitchFamily="34" charset="-122"/>
                 <a:cs typeface="Galmuri11" pitchFamily="34" charset="-120"/>
               </a:rPr>
-              <a:t>11월</a:t>
+              <a:t>5~7주 · 현재</a:t>
             </a:r>
             <a:endParaRPr lang="ko-KR" sz="1300" dirty="0"/>
           </a:p>
@@ -14804,14 +14804,14 @@
         </p:nvSpPr>
         <p:spPr>
           <a:xfrm>
-            <a:off x="2606040" y="2523744"/>
-            <a:ext cx="182880" cy="182880"/>
-          </a:xfrm>
-          <a:prstGeom prst="rect">
-            <a:avLst/>
-          </a:prstGeom>
-          <a:solidFill>
-            <a:srgbClr val="45C7C1"/>
+            <a:off x="2880360" y="2478024"/>
+            <a:ext cx="274320" cy="274320"/>
+          </a:xfrm>
+          <a:prstGeom prst="rect">
+            <a:avLst/>
+          </a:prstGeom>
+          <a:solidFill>
+            <a:srgbClr val="F7D84A"/>
           </a:solidFill>
           <a:ln/>
         </p:spPr>
@@ -14824,8 +14824,8 @@
         </p:nvSpPr>
         <p:spPr>
           <a:xfrm>
-            <a:off x="1920240" y="2834640"/>
-            <a:ext cx="1554480" cy="640080"/>
+            <a:off x="2167128" y="2834640"/>
+            <a:ext cx="1700784" cy="731520"/>
           </a:xfrm>
           <a:prstGeom prst="rect">
             <a:avLst/>
@@ -14852,7 +14852,7 @@
                 <a:ea typeface="맑은 고딕" pitchFamily="34" charset="-122"/>
                 <a:cs typeface="맑은 고딕" pitchFamily="34" charset="-120"/>
               </a:rPr>
-              <a:t>사례 14개 다듬기</a:t>
+              <a:t>게임 흐름·화면 설계</a:t>
             </a:r>
             <a:endParaRPr lang="ko-KR" sz="1100" dirty="0"/>
           </a:p>
@@ -14872,91 +14872,10 @@
                 <a:ea typeface="맑은 고딕" pitchFamily="34" charset="-122"/>
                 <a:cs typeface="맑은 고딕" pitchFamily="34" charset="-120"/>
               </a:rPr>
-              <a:t>여러 세대 시제품 테스트</a:t>
+              <a:t>HTML 시제품</a:t>
             </a:r>
             <a:endParaRPr lang="ko-KR" sz="1100" dirty="0"/>
           </a:p>
-        </p:txBody>
-      </p:sp>
-      <p:sp>
-        <p:nvSpPr>
-          <p:cNvPr id="31" name="Text 29"/>
-          <p:cNvSpPr txBox="1"/>
-          <p:nvPr/>
-        </p:nvSpPr>
-        <p:spPr>
-          <a:xfrm>
-            <a:off x="3429000" y="2029968"/>
-            <a:ext cx="1645920" cy="292608"/>
-          </a:xfrm>
-          <a:prstGeom prst="rect">
-            <a:avLst/>
-          </a:prstGeom>
-          <a:noFill/>
-          <a:ln/>
-        </p:spPr>
-        <p:txBody>
-          <a:bodyPr wrap="square" lIns="0" tIns="0" rIns="0" bIns="0" rtlCol="0" anchor="t"/>
-          <a:lstStyle/>
-          <a:p>
-            <a:pPr algn="ctr" indent="0" marL="0">
-              <a:buNone/>
-            </a:pPr>
-            <a:r>
-              <a:rPr lang="ko-KR" altLang="en-US" sz="1300" b="1" dirty="0">
-                <a:solidFill>
-                  <a:srgbClr val="FFFFFF"/>
-                </a:solidFill>
-                <a:latin typeface="Galmuri11" pitchFamily="34" charset="0"/>
-                <a:ea typeface="Galmuri11" pitchFamily="34" charset="-122"/>
-                <a:cs typeface="Galmuri11" pitchFamily="34" charset="-120"/>
-              </a:rPr>
-              <a:t>12월</a:t>
-            </a:r>
-            <a:endParaRPr lang="ko-KR" sz="1300" dirty="0"/>
-          </a:p>
-        </p:txBody>
-      </p:sp>
-      <p:sp>
-        <p:nvSpPr>
-          <p:cNvPr id="32" name="Shape 30"/>
-          <p:cNvSpPr/>
-          <p:nvPr/>
-        </p:nvSpPr>
-        <p:spPr>
-          <a:xfrm>
-            <a:off x="4160520" y="2523744"/>
-            <a:ext cx="182880" cy="182880"/>
-          </a:xfrm>
-          <a:prstGeom prst="rect">
-            <a:avLst/>
-          </a:prstGeom>
-          <a:solidFill>
-            <a:srgbClr val="45C7C1"/>
-          </a:solidFill>
-          <a:ln/>
-        </p:spPr>
-      </p:sp>
-      <p:sp>
-        <p:nvSpPr>
-          <p:cNvPr id="33" name="Text 31"/>
-          <p:cNvSpPr txBox="1"/>
-          <p:nvPr/>
-        </p:nvSpPr>
-        <p:spPr>
-          <a:xfrm>
-            <a:off x="3474720" y="2834640"/>
-            <a:ext cx="1554480" cy="640080"/>
-          </a:xfrm>
-          <a:prstGeom prst="rect">
-            <a:avLst/>
-          </a:prstGeom>
-          <a:noFill/>
-          <a:ln/>
-        </p:spPr>
-        <p:txBody>
-          <a:bodyPr wrap="square" lIns="0" tIns="0" rIns="0" bIns="0" rtlCol="0" anchor="t"/>
-          <a:lstStyle/>
           <a:p>
             <a:pPr algn="ctr" indent="0" marL="0">
               <a:lnSpc>
@@ -14973,10 +14892,91 @@
                 <a:ea typeface="맑은 고딕" pitchFamily="34" charset="-122"/>
                 <a:cs typeface="맑은 고딕" pitchFamily="34" charset="-120"/>
               </a:rPr>
-              <a:t>기말발표</a:t>
+              <a:t>중간발표</a:t>
             </a:r>
             <a:endParaRPr lang="ko-KR" sz="1100" dirty="0"/>
           </a:p>
+        </p:txBody>
+      </p:sp>
+      <p:sp>
+        <p:nvSpPr>
+          <p:cNvPr id="31" name="Text 29"/>
+          <p:cNvSpPr txBox="1"/>
+          <p:nvPr/>
+        </p:nvSpPr>
+        <p:spPr>
+          <a:xfrm>
+            <a:off x="3931920" y="2029968"/>
+            <a:ext cx="1645920" cy="292608"/>
+          </a:xfrm>
+          <a:prstGeom prst="rect">
+            <a:avLst/>
+          </a:prstGeom>
+          <a:noFill/>
+          <a:ln/>
+        </p:spPr>
+        <p:txBody>
+          <a:bodyPr wrap="square" lIns="0" tIns="0" rIns="0" bIns="0" rtlCol="0" anchor="t"/>
+          <a:lstStyle/>
+          <a:p>
+            <a:pPr algn="ctr" indent="0" marL="0">
+              <a:buNone/>
+            </a:pPr>
+            <a:r>
+              <a:rPr lang="ko-KR" altLang="en-US" sz="1300" b="1" dirty="0">
+                <a:solidFill>
+                  <a:srgbClr val="FFFFFF"/>
+                </a:solidFill>
+                <a:latin typeface="Galmuri11" pitchFamily="34" charset="0"/>
+                <a:ea typeface="Galmuri11" pitchFamily="34" charset="-122"/>
+                <a:cs typeface="Galmuri11" pitchFamily="34" charset="-120"/>
+              </a:rPr>
+              <a:t>8~10주</a:t>
+            </a:r>
+            <a:endParaRPr lang="ko-KR" sz="1300" dirty="0"/>
+          </a:p>
+        </p:txBody>
+      </p:sp>
+      <p:sp>
+        <p:nvSpPr>
+          <p:cNvPr id="32" name="Shape 30"/>
+          <p:cNvSpPr/>
+          <p:nvPr/>
+        </p:nvSpPr>
+        <p:spPr>
+          <a:xfrm>
+            <a:off x="4663440" y="2523744"/>
+            <a:ext cx="182880" cy="182880"/>
+          </a:xfrm>
+          <a:prstGeom prst="rect">
+            <a:avLst/>
+          </a:prstGeom>
+          <a:solidFill>
+            <a:srgbClr val="45C7C1"/>
+          </a:solidFill>
+          <a:ln/>
+        </p:spPr>
+      </p:sp>
+      <p:sp>
+        <p:nvSpPr>
+          <p:cNvPr id="33" name="Text 31"/>
+          <p:cNvSpPr txBox="1"/>
+          <p:nvPr/>
+        </p:nvSpPr>
+        <p:spPr>
+          <a:xfrm>
+            <a:off x="3904488" y="2834640"/>
+            <a:ext cx="1700784" cy="731520"/>
+          </a:xfrm>
+          <a:prstGeom prst="rect">
+            <a:avLst/>
+          </a:prstGeom>
+          <a:noFill/>
+          <a:ln/>
+        </p:spPr>
+        <p:txBody>
+          <a:bodyPr wrap="square" lIns="0" tIns="0" rIns="0" bIns="0" rtlCol="0" anchor="t"/>
+          <a:lstStyle/>
           <a:p>
             <a:pPr algn="ctr" indent="0" marL="0">
               <a:lnSpc>
@@ -14993,91 +14993,10 @@
                 <a:ea typeface="맑은 고딕" pitchFamily="34" charset="-122"/>
                 <a:cs typeface="맑은 고딕" pitchFamily="34" charset="-120"/>
               </a:rPr>
-              <a:t>기능·화면 확정</a:t>
+              <a:t>보안 수칙·사례 규칙</a:t>
             </a:r>
             <a:endParaRPr lang="ko-KR" sz="1100" dirty="0"/>
           </a:p>
-        </p:txBody>
-      </p:sp>
-      <p:sp>
-        <p:nvSpPr>
-          <p:cNvPr id="34" name="Text 32"/>
-          <p:cNvSpPr txBox="1"/>
-          <p:nvPr/>
-        </p:nvSpPr>
-        <p:spPr>
-          <a:xfrm>
-            <a:off x="5074920" y="2029968"/>
-            <a:ext cx="1645920" cy="292608"/>
-          </a:xfrm>
-          <a:prstGeom prst="rect">
-            <a:avLst/>
-          </a:prstGeom>
-          <a:noFill/>
-          <a:ln/>
-        </p:spPr>
-        <p:txBody>
-          <a:bodyPr wrap="square" lIns="0" tIns="0" rIns="0" bIns="0" rtlCol="0" anchor="t"/>
-          <a:lstStyle/>
-          <a:p>
-            <a:pPr algn="ctr" indent="0" marL="0">
-              <a:buNone/>
-            </a:pPr>
-            <a:r>
-              <a:rPr lang="ko-KR" altLang="en-US" sz="1300" b="1" dirty="0">
-                <a:solidFill>
-                  <a:srgbClr val="FFFFFF"/>
-                </a:solidFill>
-                <a:latin typeface="Galmuri11" pitchFamily="34" charset="0"/>
-                <a:ea typeface="Galmuri11" pitchFamily="34" charset="-122"/>
-                <a:cs typeface="Galmuri11" pitchFamily="34" charset="-120"/>
-              </a:rPr>
-              <a:t>3월</a:t>
-            </a:r>
-            <a:endParaRPr lang="ko-KR" sz="1300" dirty="0"/>
-          </a:p>
-        </p:txBody>
-      </p:sp>
-      <p:sp>
-        <p:nvSpPr>
-          <p:cNvPr id="35" name="Shape 33"/>
-          <p:cNvSpPr/>
-          <p:nvPr/>
-        </p:nvSpPr>
-        <p:spPr>
-          <a:xfrm>
-            <a:off x="5806440" y="2523744"/>
-            <a:ext cx="182880" cy="182880"/>
-          </a:xfrm>
-          <a:prstGeom prst="rect">
-            <a:avLst/>
-          </a:prstGeom>
-          <a:solidFill>
-            <a:srgbClr val="45C7C1"/>
-          </a:solidFill>
-          <a:ln/>
-        </p:spPr>
-      </p:sp>
-      <p:sp>
-        <p:nvSpPr>
-          <p:cNvPr id="36" name="Text 34"/>
-          <p:cNvSpPr txBox="1"/>
-          <p:nvPr/>
-        </p:nvSpPr>
-        <p:spPr>
-          <a:xfrm>
-            <a:off x="5120640" y="2834640"/>
-            <a:ext cx="1554480" cy="640080"/>
-          </a:xfrm>
-          <a:prstGeom prst="rect">
-            <a:avLst/>
-          </a:prstGeom>
-          <a:noFill/>
-          <a:ln/>
-        </p:spPr>
-        <p:txBody>
-          <a:bodyPr wrap="square" lIns="0" tIns="0" rIns="0" bIns="0" rtlCol="0" anchor="t"/>
-          <a:lstStyle/>
           <a:p>
             <a:pPr algn="ctr" indent="0" marL="0">
               <a:lnSpc>
@@ -15094,10 +15013,91 @@
                 <a:ea typeface="맑은 고딕" pitchFamily="34" charset="-122"/>
                 <a:cs typeface="맑은 고딕" pitchFamily="34" charset="-120"/>
               </a:rPr>
-              <a:t>Unity 화면 틀</a:t>
+              <a:t>저장 데이터 설계</a:t>
             </a:r>
             <a:endParaRPr lang="ko-KR" sz="1100" dirty="0"/>
           </a:p>
+        </p:txBody>
+      </p:sp>
+      <p:sp>
+        <p:nvSpPr>
+          <p:cNvPr id="34" name="Text 32"/>
+          <p:cNvSpPr txBox="1"/>
+          <p:nvPr/>
+        </p:nvSpPr>
+        <p:spPr>
+          <a:xfrm>
+            <a:off x="5669280" y="2029968"/>
+            <a:ext cx="1645920" cy="292608"/>
+          </a:xfrm>
+          <a:prstGeom prst="rect">
+            <a:avLst/>
+          </a:prstGeom>
+          <a:noFill/>
+          <a:ln/>
+        </p:spPr>
+        <p:txBody>
+          <a:bodyPr wrap="square" lIns="0" tIns="0" rIns="0" bIns="0" rtlCol="0" anchor="t"/>
+          <a:lstStyle/>
+          <a:p>
+            <a:pPr algn="ctr" indent="0" marL="0">
+              <a:buNone/>
+            </a:pPr>
+            <a:r>
+              <a:rPr lang="ko-KR" altLang="en-US" sz="1300" b="1" dirty="0">
+                <a:solidFill>
+                  <a:srgbClr val="FFFFFF"/>
+                </a:solidFill>
+                <a:latin typeface="Galmuri11" pitchFamily="34" charset="0"/>
+                <a:ea typeface="Galmuri11" pitchFamily="34" charset="-122"/>
+                <a:cs typeface="Galmuri11" pitchFamily="34" charset="-120"/>
+              </a:rPr>
+              <a:t>11~13주</a:t>
+            </a:r>
+            <a:endParaRPr lang="ko-KR" sz="1300" dirty="0"/>
+          </a:p>
+        </p:txBody>
+      </p:sp>
+      <p:sp>
+        <p:nvSpPr>
+          <p:cNvPr id="35" name="Shape 33"/>
+          <p:cNvSpPr/>
+          <p:nvPr/>
+        </p:nvSpPr>
+        <p:spPr>
+          <a:xfrm>
+            <a:off x="6400800" y="2523744"/>
+            <a:ext cx="182880" cy="182880"/>
+          </a:xfrm>
+          <a:prstGeom prst="rect">
+            <a:avLst/>
+          </a:prstGeom>
+          <a:solidFill>
+            <a:srgbClr val="45C7C1"/>
+          </a:solidFill>
+          <a:ln/>
+        </p:spPr>
+      </p:sp>
+      <p:sp>
+        <p:nvSpPr>
+          <p:cNvPr id="36" name="Text 34"/>
+          <p:cNvSpPr txBox="1"/>
+          <p:nvPr/>
+        </p:nvSpPr>
+        <p:spPr>
+          <a:xfrm>
+            <a:off x="5641848" y="2834640"/>
+            <a:ext cx="1700784" cy="731520"/>
+          </a:xfrm>
+          <a:prstGeom prst="rect">
+            <a:avLst/>
+          </a:prstGeom>
+          <a:noFill/>
+          <a:ln/>
+        </p:spPr>
+        <p:txBody>
+          <a:bodyPr wrap="square" lIns="0" tIns="0" rIns="0" bIns="0" rtlCol="0" anchor="t"/>
+          <a:lstStyle/>
           <a:p>
             <a:pPr algn="ctr" indent="0" marL="0">
               <a:lnSpc>
@@ -15114,91 +15114,10 @@
                 <a:ea typeface="맑은 고딕" pitchFamily="34" charset="-122"/>
                 <a:cs typeface="맑은 고딕" pitchFamily="34" charset="-120"/>
               </a:rPr>
-              <a:t>사례 데이터 불러오기</a:t>
+              <a:t>Unity 프로토타입</a:t>
             </a:r>
             <a:endParaRPr lang="ko-KR" sz="1100" dirty="0"/>
           </a:p>
-        </p:txBody>
-      </p:sp>
-      <p:sp>
-        <p:nvSpPr>
-          <p:cNvPr id="37" name="Text 35"/>
-          <p:cNvSpPr txBox="1"/>
-          <p:nvPr/>
-        </p:nvSpPr>
-        <p:spPr>
-          <a:xfrm>
-            <a:off x="6858000" y="2029968"/>
-            <a:ext cx="1645920" cy="292608"/>
-          </a:xfrm>
-          <a:prstGeom prst="rect">
-            <a:avLst/>
-          </a:prstGeom>
-          <a:noFill/>
-          <a:ln/>
-        </p:spPr>
-        <p:txBody>
-          <a:bodyPr wrap="square" lIns="0" tIns="0" rIns="0" bIns="0" rtlCol="0" anchor="t"/>
-          <a:lstStyle/>
-          <a:p>
-            <a:pPr algn="ctr" indent="0" marL="0">
-              <a:buNone/>
-            </a:pPr>
-            <a:r>
-              <a:rPr lang="ko-KR" altLang="en-US" sz="1300" b="1" dirty="0">
-                <a:solidFill>
-                  <a:srgbClr val="FFFFFF"/>
-                </a:solidFill>
-                <a:latin typeface="Galmuri11" pitchFamily="34" charset="0"/>
-                <a:ea typeface="Galmuri11" pitchFamily="34" charset="-122"/>
-                <a:cs typeface="Galmuri11" pitchFamily="34" charset="-120"/>
-              </a:rPr>
-              <a:t>4월</a:t>
-            </a:r>
-            <a:endParaRPr lang="ko-KR" sz="1300" dirty="0"/>
-          </a:p>
-        </p:txBody>
-      </p:sp>
-      <p:sp>
-        <p:nvSpPr>
-          <p:cNvPr id="38" name="Shape 36"/>
-          <p:cNvSpPr/>
-          <p:nvPr/>
-        </p:nvSpPr>
-        <p:spPr>
-          <a:xfrm>
-            <a:off x="7589520" y="2523744"/>
-            <a:ext cx="182880" cy="182880"/>
-          </a:xfrm>
-          <a:prstGeom prst="rect">
-            <a:avLst/>
-          </a:prstGeom>
-          <a:solidFill>
-            <a:srgbClr val="45C7C1"/>
-          </a:solidFill>
-          <a:ln/>
-        </p:spPr>
-      </p:sp>
-      <p:sp>
-        <p:nvSpPr>
-          <p:cNvPr id="39" name="Text 37"/>
-          <p:cNvSpPr txBox="1"/>
-          <p:nvPr/>
-        </p:nvSpPr>
-        <p:spPr>
-          <a:xfrm>
-            <a:off x="6903720" y="2834640"/>
-            <a:ext cx="1554480" cy="640080"/>
-          </a:xfrm>
-          <a:prstGeom prst="rect">
-            <a:avLst/>
-          </a:prstGeom>
-          <a:noFill/>
-          <a:ln/>
-        </p:spPr>
-        <p:txBody>
-          <a:bodyPr wrap="square" lIns="0" tIns="0" rIns="0" bIns="0" rtlCol="0" anchor="t"/>
-          <a:lstStyle/>
           <a:p>
             <a:pPr algn="ctr" indent="0" marL="0">
               <a:lnSpc>
@@ -15215,10 +15134,91 @@
                 <a:ea typeface="맑은 고딕" pitchFamily="34" charset="-122"/>
                 <a:cs typeface="맑은 고딕" pitchFamily="34" charset="-120"/>
               </a:rPr>
-              <a:t>판정 엔진</a:t>
+              <a:t>판정 엔진·하루치 사례</a:t>
             </a:r>
             <a:endParaRPr lang="ko-KR" sz="1100" dirty="0"/>
           </a:p>
+        </p:txBody>
+      </p:sp>
+      <p:sp>
+        <p:nvSpPr>
+          <p:cNvPr id="37" name="Text 35"/>
+          <p:cNvSpPr txBox="1"/>
+          <p:nvPr/>
+        </p:nvSpPr>
+        <p:spPr>
+          <a:xfrm>
+            <a:off x="7406640" y="2029968"/>
+            <a:ext cx="1645920" cy="292608"/>
+          </a:xfrm>
+          <a:prstGeom prst="rect">
+            <a:avLst/>
+          </a:prstGeom>
+          <a:noFill/>
+          <a:ln/>
+        </p:spPr>
+        <p:txBody>
+          <a:bodyPr wrap="square" lIns="0" tIns="0" rIns="0" bIns="0" rtlCol="0" anchor="t"/>
+          <a:lstStyle/>
+          <a:p>
+            <a:pPr algn="ctr" indent="0" marL="0">
+              <a:buNone/>
+            </a:pPr>
+            <a:r>
+              <a:rPr lang="ko-KR" altLang="en-US" sz="1300" b="1" dirty="0">
+                <a:solidFill>
+                  <a:srgbClr val="FFFFFF"/>
+                </a:solidFill>
+                <a:latin typeface="Galmuri11" pitchFamily="34" charset="0"/>
+                <a:ea typeface="Galmuri11" pitchFamily="34" charset="-122"/>
+                <a:cs typeface="Galmuri11" pitchFamily="34" charset="-120"/>
+              </a:rPr>
+              <a:t>14~15주</a:t>
+            </a:r>
+            <a:endParaRPr lang="ko-KR" sz="1300" dirty="0"/>
+          </a:p>
+        </p:txBody>
+      </p:sp>
+      <p:sp>
+        <p:nvSpPr>
+          <p:cNvPr id="38" name="Shape 36"/>
+          <p:cNvSpPr/>
+          <p:nvPr/>
+        </p:nvSpPr>
+        <p:spPr>
+          <a:xfrm>
+            <a:off x="8138160" y="2523744"/>
+            <a:ext cx="182880" cy="182880"/>
+          </a:xfrm>
+          <a:prstGeom prst="rect">
+            <a:avLst/>
+          </a:prstGeom>
+          <a:solidFill>
+            <a:srgbClr val="45C7C1"/>
+          </a:solidFill>
+          <a:ln/>
+        </p:spPr>
+      </p:sp>
+      <p:sp>
+        <p:nvSpPr>
+          <p:cNvPr id="39" name="Text 37"/>
+          <p:cNvSpPr txBox="1"/>
+          <p:nvPr/>
+        </p:nvSpPr>
+        <p:spPr>
+          <a:xfrm>
+            <a:off x="7379208" y="2834640"/>
+            <a:ext cx="1700784" cy="731520"/>
+          </a:xfrm>
+          <a:prstGeom prst="rect">
+            <a:avLst/>
+          </a:prstGeom>
+          <a:noFill/>
+          <a:ln/>
+        </p:spPr>
+        <p:txBody>
+          <a:bodyPr wrap="square" lIns="0" tIns="0" rIns="0" bIns="0" rtlCol="0" anchor="t"/>
+          <a:lstStyle/>
           <a:p>
             <a:pPr algn="ctr" indent="0" marL="0">
               <a:lnSpc>
@@ -15235,91 +15235,10 @@
                 <a:ea typeface="맑은 고딕" pitchFamily="34" charset="-122"/>
                 <a:cs typeface="맑은 고딕" pitchFamily="34" charset="-120"/>
               </a:rPr>
-              <a:t>Day 0~4 만들기</a:t>
+              <a:t>테스트·산출물 정리</a:t>
             </a:r>
             <a:endParaRPr lang="ko-KR" sz="1100" dirty="0"/>
           </a:p>
-        </p:txBody>
-      </p:sp>
-      <p:sp>
-        <p:nvSpPr>
-          <p:cNvPr id="40" name="Text 38"/>
-          <p:cNvSpPr txBox="1"/>
-          <p:nvPr/>
-        </p:nvSpPr>
-        <p:spPr>
-          <a:xfrm>
-            <a:off x="8595360" y="2029968"/>
-            <a:ext cx="1645920" cy="292608"/>
-          </a:xfrm>
-          <a:prstGeom prst="rect">
-            <a:avLst/>
-          </a:prstGeom>
-          <a:noFill/>
-          <a:ln/>
-        </p:spPr>
-        <p:txBody>
-          <a:bodyPr wrap="square" lIns="0" tIns="0" rIns="0" bIns="0" rtlCol="0" anchor="t"/>
-          <a:lstStyle/>
-          <a:p>
-            <a:pPr algn="ctr" indent="0" marL="0">
-              <a:buNone/>
-            </a:pPr>
-            <a:r>
-              <a:rPr lang="ko-KR" altLang="en-US" sz="1300" b="1" dirty="0">
-                <a:solidFill>
-                  <a:srgbClr val="FFFFFF"/>
-                </a:solidFill>
-                <a:latin typeface="Galmuri11" pitchFamily="34" charset="0"/>
-                <a:ea typeface="Galmuri11" pitchFamily="34" charset="-122"/>
-                <a:cs typeface="Galmuri11" pitchFamily="34" charset="-120"/>
-              </a:rPr>
-              <a:t>5월</a:t>
-            </a:r>
-            <a:endParaRPr lang="ko-KR" sz="1300" dirty="0"/>
-          </a:p>
-        </p:txBody>
-      </p:sp>
-      <p:sp>
-        <p:nvSpPr>
-          <p:cNvPr id="41" name="Shape 39"/>
-          <p:cNvSpPr/>
-          <p:nvPr/>
-        </p:nvSpPr>
-        <p:spPr>
-          <a:xfrm>
-            <a:off x="9326880" y="2523744"/>
-            <a:ext cx="182880" cy="182880"/>
-          </a:xfrm>
-          <a:prstGeom prst="rect">
-            <a:avLst/>
-          </a:prstGeom>
-          <a:solidFill>
-            <a:srgbClr val="45C7C1"/>
-          </a:solidFill>
-          <a:ln/>
-        </p:spPr>
-      </p:sp>
-      <p:sp>
-        <p:nvSpPr>
-          <p:cNvPr id="42" name="Text 40"/>
-          <p:cNvSpPr txBox="1"/>
-          <p:nvPr/>
-        </p:nvSpPr>
-        <p:spPr>
-          <a:xfrm>
-            <a:off x="8641080" y="2834640"/>
-            <a:ext cx="1554480" cy="640080"/>
-          </a:xfrm>
-          <a:prstGeom prst="rect">
-            <a:avLst/>
-          </a:prstGeom>
-          <a:noFill/>
-          <a:ln/>
-        </p:spPr>
-        <p:txBody>
-          <a:bodyPr wrap="square" lIns="0" tIns="0" rIns="0" bIns="0" rtlCol="0" anchor="t"/>
-          <a:lstStyle/>
           <a:p>
             <a:pPr algn="ctr" indent="0" marL="0">
               <a:lnSpc>
@@ -15336,10 +15255,91 @@
                 <a:ea typeface="맑은 고딕" pitchFamily="34" charset="-122"/>
                 <a:cs typeface="맑은 고딕" pitchFamily="34" charset="-120"/>
               </a:rPr>
-              <a:t>여러 세대 10명</a:t>
+              <a:t>기말발표</a:t>
             </a:r>
             <a:endParaRPr lang="ko-KR" sz="1100" dirty="0"/>
           </a:p>
+        </p:txBody>
+      </p:sp>
+      <p:sp>
+        <p:nvSpPr>
+          <p:cNvPr id="40" name="Text 38"/>
+          <p:cNvSpPr txBox="1"/>
+          <p:nvPr/>
+        </p:nvSpPr>
+        <p:spPr>
+          <a:xfrm>
+            <a:off x="9729216" y="2029968"/>
+            <a:ext cx="1645920" cy="292608"/>
+          </a:xfrm>
+          <a:prstGeom prst="rect">
+            <a:avLst/>
+          </a:prstGeom>
+          <a:noFill/>
+          <a:ln/>
+        </p:spPr>
+        <p:txBody>
+          <a:bodyPr wrap="square" lIns="0" tIns="0" rIns="0" bIns="0" rtlCol="0" anchor="t"/>
+          <a:lstStyle/>
+          <a:p>
+            <a:pPr algn="ctr" indent="0" marL="0">
+              <a:buNone/>
+            </a:pPr>
+            <a:r>
+              <a:rPr lang="ko-KR" altLang="en-US" sz="1300" b="1" dirty="0">
+                <a:solidFill>
+                  <a:srgbClr val="FFFFFF"/>
+                </a:solidFill>
+                <a:latin typeface="Galmuri11" pitchFamily="34" charset="0"/>
+                <a:ea typeface="Galmuri11" pitchFamily="34" charset="-122"/>
+                <a:cs typeface="Galmuri11" pitchFamily="34" charset="-120"/>
+              </a:rPr>
+              <a:t>다음 학기</a:t>
+            </a:r>
+            <a:endParaRPr lang="ko-KR" sz="1300" dirty="0"/>
+          </a:p>
+        </p:txBody>
+      </p:sp>
+      <p:sp>
+        <p:nvSpPr>
+          <p:cNvPr id="41" name="Shape 39"/>
+          <p:cNvSpPr/>
+          <p:nvPr/>
+        </p:nvSpPr>
+        <p:spPr>
+          <a:xfrm>
+            <a:off x="10460736" y="2523744"/>
+            <a:ext cx="182880" cy="182880"/>
+          </a:xfrm>
+          <a:prstGeom prst="rect">
+            <a:avLst/>
+          </a:prstGeom>
+          <a:solidFill>
+            <a:srgbClr val="45C7C1"/>
+          </a:solidFill>
+          <a:ln/>
+        </p:spPr>
+      </p:sp>
+      <p:sp>
+        <p:nvSpPr>
+          <p:cNvPr id="42" name="Text 40"/>
+          <p:cNvSpPr txBox="1"/>
+          <p:nvPr/>
+        </p:nvSpPr>
+        <p:spPr>
+          <a:xfrm>
+            <a:off x="9701784" y="2834640"/>
+            <a:ext cx="1700784" cy="731520"/>
+          </a:xfrm>
+          <a:prstGeom prst="rect">
+            <a:avLst/>
+          </a:prstGeom>
+          <a:noFill/>
+          <a:ln/>
+        </p:spPr>
+        <p:txBody>
+          <a:bodyPr wrap="square" lIns="0" tIns="0" rIns="0" bIns="0" rtlCol="0" anchor="t"/>
+          <a:lstStyle/>
           <a:p>
             <a:pPr algn="ctr" indent="0" marL="0">
               <a:lnSpc>
@@ -15356,91 +15356,10 @@
                 <a:ea typeface="맑은 고딕" pitchFamily="34" charset="-122"/>
                 <a:cs typeface="맑은 고딕" pitchFamily="34" charset="-120"/>
               </a:rPr>
-              <a:t>직접 해 보기</a:t>
+              <a:t>전체 기능·사례 확충</a:t>
             </a:r>
             <a:endParaRPr lang="ko-KR" sz="1100" dirty="0"/>
           </a:p>
-        </p:txBody>
-      </p:sp>
-      <p:sp>
-        <p:nvSpPr>
-          <p:cNvPr id="43" name="Text 41"/>
-          <p:cNvSpPr txBox="1"/>
-          <p:nvPr/>
-        </p:nvSpPr>
-        <p:spPr>
-          <a:xfrm>
-            <a:off x="10241280" y="2029968"/>
-            <a:ext cx="1645920" cy="292608"/>
-          </a:xfrm>
-          <a:prstGeom prst="rect">
-            <a:avLst/>
-          </a:prstGeom>
-          <a:noFill/>
-          <a:ln/>
-        </p:spPr>
-        <p:txBody>
-          <a:bodyPr wrap="square" lIns="0" tIns="0" rIns="0" bIns="0" rtlCol="0" anchor="t"/>
-          <a:lstStyle/>
-          <a:p>
-            <a:pPr algn="ctr" indent="0" marL="0">
-              <a:buNone/>
-            </a:pPr>
-            <a:r>
-              <a:rPr lang="ko-KR" altLang="en-US" sz="1300" b="1" dirty="0">
-                <a:solidFill>
-                  <a:srgbClr val="FFFFFF"/>
-                </a:solidFill>
-                <a:latin typeface="Galmuri11" pitchFamily="34" charset="0"/>
-                <a:ea typeface="Galmuri11" pitchFamily="34" charset="-122"/>
-                <a:cs typeface="Galmuri11" pitchFamily="34" charset="-120"/>
-              </a:rPr>
-              <a:t>6월</a:t>
-            </a:r>
-            <a:endParaRPr lang="ko-KR" sz="1300" dirty="0"/>
-          </a:p>
-        </p:txBody>
-      </p:sp>
-      <p:sp>
-        <p:nvSpPr>
-          <p:cNvPr id="44" name="Shape 42"/>
-          <p:cNvSpPr/>
-          <p:nvPr/>
-        </p:nvSpPr>
-        <p:spPr>
-          <a:xfrm>
-            <a:off x="10972800" y="2523744"/>
-            <a:ext cx="182880" cy="182880"/>
-          </a:xfrm>
-          <a:prstGeom prst="rect">
-            <a:avLst/>
-          </a:prstGeom>
-          <a:solidFill>
-            <a:srgbClr val="45C7C1"/>
-          </a:solidFill>
-          <a:ln/>
-        </p:spPr>
-      </p:sp>
-      <p:sp>
-        <p:nvSpPr>
-          <p:cNvPr id="45" name="Text 43"/>
-          <p:cNvSpPr txBox="1"/>
-          <p:nvPr/>
-        </p:nvSpPr>
-        <p:spPr>
-          <a:xfrm>
-            <a:off x="10287000" y="2834640"/>
-            <a:ext cx="1554480" cy="640080"/>
-          </a:xfrm>
-          <a:prstGeom prst="rect">
-            <a:avLst/>
-          </a:prstGeom>
-          <a:noFill/>
-          <a:ln/>
-        </p:spPr>
-        <p:txBody>
-          <a:bodyPr wrap="square" lIns="0" tIns="0" rIns="0" bIns="0" rtlCol="0" anchor="t"/>
-          <a:lstStyle/>
           <a:p>
             <a:pPr algn="ctr" indent="0" marL="0">
               <a:lnSpc>
@@ -15457,35 +15376,15 @@
                 <a:ea typeface="맑은 고딕" pitchFamily="34" charset="-122"/>
                 <a:cs typeface="맑은 고딕" pitchFamily="34" charset="-120"/>
               </a:rPr>
-              <a:t>최종 발표</a:t>
+              <a:t>테스트·최종 발표</a:t>
             </a:r>
             <a:endParaRPr lang="ko-KR" sz="1100" dirty="0"/>
           </a:p>
-          <a:p>
-            <a:pPr algn="ctr" indent="0" marL="0">
-              <a:lnSpc>
-                <a:spcPct val="105000"/>
-              </a:lnSpc>
-              <a:buNone/>
-            </a:pPr>
-            <a:r>
-              <a:rPr lang="ko-KR" altLang="en-US" sz="1100" dirty="0">
-                <a:solidFill>
-                  <a:srgbClr val="B9C6E2"/>
-                </a:solidFill>
-                <a:latin typeface="맑은 고딕" pitchFamily="34" charset="0"/>
-                <a:ea typeface="맑은 고딕" pitchFamily="34" charset="-122"/>
-                <a:cs typeface="맑은 고딕" pitchFamily="34" charset="-120"/>
-              </a:rPr>
-              <a:t>시연</a:t>
-            </a:r>
-            <a:endParaRPr lang="ko-KR" sz="1100" dirty="0"/>
-          </a:p>
         </p:txBody>
       </p:sp>
       <p:sp>
         <p:nvSpPr>
-          <p:cNvPr id="46" name="Text 44"/>
+          <p:cNvPr id="43" name="Text 41"/>
           <p:cNvSpPr txBox="1"/>
           <p:nvPr/>
         </p:nvSpPr>
@@ -15524,7 +15423,7 @@
       </p:sp>
       <p:sp>
         <p:nvSpPr>
-          <p:cNvPr id="47" name="Shape 45"/>
+          <p:cNvPr id="44" name="Shape 42"/>
           <p:cNvSpPr/>
           <p:nvPr/>
         </p:nvSpPr>
@@ -15544,7 +15443,7 @@
       </p:sp>
       <p:sp>
         <p:nvSpPr>
-          <p:cNvPr id="48" name="Shape 46"/>
+          <p:cNvPr id="45" name="Shape 43"/>
           <p:cNvSpPr/>
           <p:nvPr/>
         </p:nvSpPr>
@@ -15564,13 +15463,73 @@
       </p:sp>
       <p:sp>
         <p:nvSpPr>
+          <p:cNvPr id="46" name="Shape 44"/>
+          <p:cNvSpPr/>
+          <p:nvPr/>
+        </p:nvSpPr>
+        <p:spPr>
+          <a:xfrm>
+            <a:off x="548640" y="4251960"/>
+            <a:ext cx="50292" cy="50292"/>
+          </a:xfrm>
+          <a:prstGeom prst="rect">
+            <a:avLst/>
+          </a:prstGeom>
+          <a:solidFill>
+            <a:srgbClr val="0F1426"/>
+          </a:solidFill>
+          <a:ln/>
+        </p:spPr>
+      </p:sp>
+      <p:sp>
+        <p:nvSpPr>
+          <p:cNvPr id="47" name="Shape 45"/>
+          <p:cNvSpPr/>
+          <p:nvPr/>
+        </p:nvSpPr>
+        <p:spPr>
+          <a:xfrm>
+            <a:off x="3150108" y="4251960"/>
+            <a:ext cx="50292" cy="50292"/>
+          </a:xfrm>
+          <a:prstGeom prst="rect">
+            <a:avLst/>
+          </a:prstGeom>
+          <a:solidFill>
+            <a:srgbClr val="0F1426"/>
+          </a:solidFill>
+          <a:ln/>
+        </p:spPr>
+      </p:sp>
+      <p:sp>
+        <p:nvSpPr>
+          <p:cNvPr id="48" name="Shape 46"/>
+          <p:cNvSpPr/>
+          <p:nvPr/>
+        </p:nvSpPr>
+        <p:spPr>
+          <a:xfrm>
+            <a:off x="548640" y="5436108"/>
+            <a:ext cx="50292" cy="50292"/>
+          </a:xfrm>
+          <a:prstGeom prst="rect">
+            <a:avLst/>
+          </a:prstGeom>
+          <a:solidFill>
+            <a:srgbClr val="0F1426"/>
+          </a:solidFill>
+          <a:ln/>
+        </p:spPr>
+      </p:sp>
+      <p:sp>
+        <p:nvSpPr>
           <p:cNvPr id="49" name="Shape 47"/>
           <p:cNvSpPr/>
           <p:nvPr/>
         </p:nvSpPr>
         <p:spPr>
           <a:xfrm>
-            <a:off x="548640" y="4251960"/>
+            <a:off x="3150108" y="5436108"/>
             <a:ext cx="50292" cy="50292"/>
           </a:xfrm>
           <a:prstGeom prst="rect">
@@ -15585,66 +15544,6 @@
       <p:sp>
         <p:nvSpPr>
           <p:cNvPr id="50" name="Shape 48"/>
-          <p:cNvSpPr/>
-          <p:nvPr/>
-        </p:nvSpPr>
-        <p:spPr>
-          <a:xfrm>
-            <a:off x="3150108" y="4251960"/>
-            <a:ext cx="50292" cy="50292"/>
-          </a:xfrm>
-          <a:prstGeom prst="rect">
-            <a:avLst/>
-          </a:prstGeom>
-          <a:solidFill>
-            <a:srgbClr val="0F1426"/>
-          </a:solidFill>
-          <a:ln/>
-        </p:spPr>
-      </p:sp>
-      <p:sp>
-        <p:nvSpPr>
-          <p:cNvPr id="51" name="Shape 49"/>
-          <p:cNvSpPr/>
-          <p:nvPr/>
-        </p:nvSpPr>
-        <p:spPr>
-          <a:xfrm>
-            <a:off x="548640" y="5436108"/>
-            <a:ext cx="50292" cy="50292"/>
-          </a:xfrm>
-          <a:prstGeom prst="rect">
-            <a:avLst/>
-          </a:prstGeom>
-          <a:solidFill>
-            <a:srgbClr val="0F1426"/>
-          </a:solidFill>
-          <a:ln/>
-        </p:spPr>
-      </p:sp>
-      <p:sp>
-        <p:nvSpPr>
-          <p:cNvPr id="52" name="Shape 50"/>
-          <p:cNvSpPr/>
-          <p:nvPr/>
-        </p:nvSpPr>
-        <p:spPr>
-          <a:xfrm>
-            <a:off x="3150108" y="5436108"/>
-            <a:ext cx="50292" cy="50292"/>
-          </a:xfrm>
-          <a:prstGeom prst="rect">
-            <a:avLst/>
-          </a:prstGeom>
-          <a:solidFill>
-            <a:srgbClr val="0F1426"/>
-          </a:solidFill>
-          <a:ln/>
-        </p:spPr>
-      </p:sp>
-      <p:sp>
-        <p:nvSpPr>
-          <p:cNvPr id="53" name="Shape 51"/>
           <p:cNvSpPr/>
           <p:nvPr/>
         </p:nvSpPr>
@@ -15664,7 +15563,7 @@
       </p:sp>
       <p:sp>
         <p:nvSpPr>
-          <p:cNvPr id="54" name="Shape 52"/>
+          <p:cNvPr id="51" name="Shape 49"/>
           <p:cNvSpPr/>
           <p:nvPr/>
         </p:nvSpPr>
@@ -15684,13 +15583,73 @@
       </p:sp>
       <p:sp>
         <p:nvSpPr>
+          <p:cNvPr id="52" name="Shape 50"/>
+          <p:cNvSpPr/>
+          <p:nvPr/>
+        </p:nvSpPr>
+        <p:spPr>
+          <a:xfrm>
+            <a:off x="749808" y="4434840"/>
+            <a:ext cx="50292" cy="50292"/>
+          </a:xfrm>
+          <a:prstGeom prst="rect">
+            <a:avLst/>
+          </a:prstGeom>
+          <a:solidFill>
+            <a:srgbClr val="1F2A4A"/>
+          </a:solidFill>
+          <a:ln/>
+        </p:spPr>
+      </p:sp>
+      <p:sp>
+        <p:nvSpPr>
+          <p:cNvPr id="53" name="Shape 51"/>
+          <p:cNvSpPr/>
+          <p:nvPr/>
+        </p:nvSpPr>
+        <p:spPr>
+          <a:xfrm>
+            <a:off x="1156716" y="4434840"/>
+            <a:ext cx="50292" cy="50292"/>
+          </a:xfrm>
+          <a:prstGeom prst="rect">
+            <a:avLst/>
+          </a:prstGeom>
+          <a:solidFill>
+            <a:srgbClr val="1F2A4A"/>
+          </a:solidFill>
+          <a:ln/>
+        </p:spPr>
+      </p:sp>
+      <p:sp>
+        <p:nvSpPr>
+          <p:cNvPr id="54" name="Shape 52"/>
+          <p:cNvSpPr/>
+          <p:nvPr/>
+        </p:nvSpPr>
+        <p:spPr>
+          <a:xfrm>
+            <a:off x="749808" y="4841748"/>
+            <a:ext cx="50292" cy="50292"/>
+          </a:xfrm>
+          <a:prstGeom prst="rect">
+            <a:avLst/>
+          </a:prstGeom>
+          <a:solidFill>
+            <a:srgbClr val="1F2A4A"/>
+          </a:solidFill>
+          <a:ln/>
+        </p:spPr>
+      </p:sp>
+      <p:sp>
+        <p:nvSpPr>
           <p:cNvPr id="55" name="Shape 53"/>
           <p:cNvSpPr/>
           <p:nvPr/>
         </p:nvSpPr>
         <p:spPr>
           <a:xfrm>
-            <a:off x="749808" y="4434840"/>
+            <a:off x="1156716" y="4841748"/>
             <a:ext cx="50292" cy="50292"/>
           </a:xfrm>
           <a:prstGeom prst="rect">
@@ -15704,67 +15663,7 @@
       </p:sp>
       <p:sp>
         <p:nvSpPr>
-          <p:cNvPr id="56" name="Shape 54"/>
-          <p:cNvSpPr/>
-          <p:nvPr/>
-        </p:nvSpPr>
-        <p:spPr>
-          <a:xfrm>
-            <a:off x="1156716" y="4434840"/>
-            <a:ext cx="50292" cy="50292"/>
-          </a:xfrm>
-          <a:prstGeom prst="rect">
-            <a:avLst/>
-          </a:prstGeom>
-          <a:solidFill>
-            <a:srgbClr val="1F2A4A"/>
-          </a:solidFill>
-          <a:ln/>
-        </p:spPr>
-      </p:sp>
-      <p:sp>
-        <p:nvSpPr>
-          <p:cNvPr id="57" name="Shape 55"/>
-          <p:cNvSpPr/>
-          <p:nvPr/>
-        </p:nvSpPr>
-        <p:spPr>
-          <a:xfrm>
-            <a:off x="749808" y="4841748"/>
-            <a:ext cx="50292" cy="50292"/>
-          </a:xfrm>
-          <a:prstGeom prst="rect">
-            <a:avLst/>
-          </a:prstGeom>
-          <a:solidFill>
-            <a:srgbClr val="1F2A4A"/>
-          </a:solidFill>
-          <a:ln/>
-        </p:spPr>
-      </p:sp>
-      <p:sp>
-        <p:nvSpPr>
-          <p:cNvPr id="58" name="Shape 56"/>
-          <p:cNvSpPr/>
-          <p:nvPr/>
-        </p:nvSpPr>
-        <p:spPr>
-          <a:xfrm>
-            <a:off x="1156716" y="4841748"/>
-            <a:ext cx="50292" cy="50292"/>
-          </a:xfrm>
-          <a:prstGeom prst="rect">
-            <a:avLst/>
-          </a:prstGeom>
-          <a:solidFill>
-            <a:srgbClr val="1F2A4A"/>
-          </a:solidFill>
-          <a:ln/>
-        </p:spPr>
-      </p:sp>
-      <p:sp>
-        <p:nvSpPr>
-          <p:cNvPr id="59" name="Text 57"/>
+          <p:cNvPr id="56" name="Text 54"/>
           <p:cNvSpPr txBox="1"/>
           <p:nvPr/>
         </p:nvSpPr>
@@ -15803,7 +15702,7 @@
       </p:sp>
       <p:sp>
         <p:nvSpPr>
-          <p:cNvPr id="60" name="Text 58"/>
+          <p:cNvPr id="57" name="Text 55"/>
           <p:cNvSpPr txBox="1"/>
           <p:nvPr/>
         </p:nvSpPr>
@@ -15842,7 +15741,7 @@
       </p:sp>
       <p:sp>
         <p:nvSpPr>
-          <p:cNvPr id="61" name="Text 59"/>
+          <p:cNvPr id="58" name="Text 56"/>
           <p:cNvSpPr txBox="1"/>
           <p:nvPr/>
         </p:nvSpPr>
@@ -15873,7 +15772,7 @@
                 <a:ea typeface="맑은 고딕" pitchFamily="34" charset="-122"/>
                 <a:cs typeface="맑은 고딕" pitchFamily="34" charset="-120"/>
               </a:rPr>
-              <a:t>일정 관리, 사례 작성·검토</a:t>
+              <a:t>기획·자료 수집·디자인·사례 개발</a:t>
             </a:r>
             <a:endParaRPr lang="ko-KR" sz="1150" dirty="0"/>
           </a:p>
@@ -15881,7 +15780,7 @@
       </p:sp>
       <p:sp>
         <p:nvSpPr>
-          <p:cNvPr id="62" name="Shape 60"/>
+          <p:cNvPr id="59" name="Shape 57"/>
           <p:cNvSpPr/>
           <p:nvPr/>
         </p:nvSpPr>
@@ -15901,7 +15800,7 @@
       </p:sp>
       <p:sp>
         <p:nvSpPr>
-          <p:cNvPr id="63" name="Shape 61"/>
+          <p:cNvPr id="60" name="Shape 58"/>
           <p:cNvSpPr/>
           <p:nvPr/>
         </p:nvSpPr>
@@ -15921,13 +15820,73 @@
       </p:sp>
       <p:sp>
         <p:nvSpPr>
+          <p:cNvPr id="61" name="Shape 59"/>
+          <p:cNvSpPr/>
+          <p:nvPr/>
+        </p:nvSpPr>
+        <p:spPr>
+          <a:xfrm>
+            <a:off x="3364992" y="4251960"/>
+            <a:ext cx="50292" cy="50292"/>
+          </a:xfrm>
+          <a:prstGeom prst="rect">
+            <a:avLst/>
+          </a:prstGeom>
+          <a:solidFill>
+            <a:srgbClr val="0F1426"/>
+          </a:solidFill>
+          <a:ln/>
+        </p:spPr>
+      </p:sp>
+      <p:sp>
+        <p:nvSpPr>
+          <p:cNvPr id="62" name="Shape 60"/>
+          <p:cNvSpPr/>
+          <p:nvPr/>
+        </p:nvSpPr>
+        <p:spPr>
+          <a:xfrm>
+            <a:off x="5966460" y="4251960"/>
+            <a:ext cx="50292" cy="50292"/>
+          </a:xfrm>
+          <a:prstGeom prst="rect">
+            <a:avLst/>
+          </a:prstGeom>
+          <a:solidFill>
+            <a:srgbClr val="0F1426"/>
+          </a:solidFill>
+          <a:ln/>
+        </p:spPr>
+      </p:sp>
+      <p:sp>
+        <p:nvSpPr>
+          <p:cNvPr id="63" name="Shape 61"/>
+          <p:cNvSpPr/>
+          <p:nvPr/>
+        </p:nvSpPr>
+        <p:spPr>
+          <a:xfrm>
+            <a:off x="3364992" y="5436108"/>
+            <a:ext cx="50292" cy="50292"/>
+          </a:xfrm>
+          <a:prstGeom prst="rect">
+            <a:avLst/>
+          </a:prstGeom>
+          <a:solidFill>
+            <a:srgbClr val="0F1426"/>
+          </a:solidFill>
+          <a:ln/>
+        </p:spPr>
+      </p:sp>
+      <p:sp>
+        <p:nvSpPr>
           <p:cNvPr id="64" name="Shape 62"/>
           <p:cNvSpPr/>
           <p:nvPr/>
         </p:nvSpPr>
         <p:spPr>
           <a:xfrm>
-            <a:off x="3364992" y="4251960"/>
+            <a:off x="5966460" y="5436108"/>
             <a:ext cx="50292" cy="50292"/>
           </a:xfrm>
           <a:prstGeom prst="rect">
@@ -15942,66 +15901,6 @@
       <p:sp>
         <p:nvSpPr>
           <p:cNvPr id="65" name="Shape 63"/>
-          <p:cNvSpPr/>
-          <p:nvPr/>
-        </p:nvSpPr>
-        <p:spPr>
-          <a:xfrm>
-            <a:off x="5966460" y="4251960"/>
-            <a:ext cx="50292" cy="50292"/>
-          </a:xfrm>
-          <a:prstGeom prst="rect">
-            <a:avLst/>
-          </a:prstGeom>
-          <a:solidFill>
-            <a:srgbClr val="0F1426"/>
-          </a:solidFill>
-          <a:ln/>
-        </p:spPr>
-      </p:sp>
-      <p:sp>
-        <p:nvSpPr>
-          <p:cNvPr id="66" name="Shape 64"/>
-          <p:cNvSpPr/>
-          <p:nvPr/>
-        </p:nvSpPr>
-        <p:spPr>
-          <a:xfrm>
-            <a:off x="3364992" y="5436108"/>
-            <a:ext cx="50292" cy="50292"/>
-          </a:xfrm>
-          <a:prstGeom prst="rect">
-            <a:avLst/>
-          </a:prstGeom>
-          <a:solidFill>
-            <a:srgbClr val="0F1426"/>
-          </a:solidFill>
-          <a:ln/>
-        </p:spPr>
-      </p:sp>
-      <p:sp>
-        <p:nvSpPr>
-          <p:cNvPr id="67" name="Shape 65"/>
-          <p:cNvSpPr/>
-          <p:nvPr/>
-        </p:nvSpPr>
-        <p:spPr>
-          <a:xfrm>
-            <a:off x="5966460" y="5436108"/>
-            <a:ext cx="50292" cy="50292"/>
-          </a:xfrm>
-          <a:prstGeom prst="rect">
-            <a:avLst/>
-          </a:prstGeom>
-          <a:solidFill>
-            <a:srgbClr val="0F1426"/>
-          </a:solidFill>
-          <a:ln/>
-        </p:spPr>
-      </p:sp>
-      <p:sp>
-        <p:nvSpPr>
-          <p:cNvPr id="68" name="Shape 66"/>
           <p:cNvSpPr/>
           <p:nvPr/>
         </p:nvSpPr>
@@ -16021,7 +15920,7 @@
       </p:sp>
       <p:sp>
         <p:nvSpPr>
-          <p:cNvPr id="69" name="Shape 67"/>
+          <p:cNvPr id="66" name="Shape 64"/>
           <p:cNvSpPr/>
           <p:nvPr/>
         </p:nvSpPr>
@@ -16041,13 +15940,73 @@
       </p:sp>
       <p:sp>
         <p:nvSpPr>
+          <p:cNvPr id="67" name="Shape 65"/>
+          <p:cNvSpPr/>
+          <p:nvPr/>
+        </p:nvSpPr>
+        <p:spPr>
+          <a:xfrm>
+            <a:off x="3566160" y="4434840"/>
+            <a:ext cx="50292" cy="50292"/>
+          </a:xfrm>
+          <a:prstGeom prst="rect">
+            <a:avLst/>
+          </a:prstGeom>
+          <a:solidFill>
+            <a:srgbClr val="1F2A4A"/>
+          </a:solidFill>
+          <a:ln/>
+        </p:spPr>
+      </p:sp>
+      <p:sp>
+        <p:nvSpPr>
+          <p:cNvPr id="68" name="Shape 66"/>
+          <p:cNvSpPr/>
+          <p:nvPr/>
+        </p:nvSpPr>
+        <p:spPr>
+          <a:xfrm>
+            <a:off x="3973068" y="4434840"/>
+            <a:ext cx="50292" cy="50292"/>
+          </a:xfrm>
+          <a:prstGeom prst="rect">
+            <a:avLst/>
+          </a:prstGeom>
+          <a:solidFill>
+            <a:srgbClr val="1F2A4A"/>
+          </a:solidFill>
+          <a:ln/>
+        </p:spPr>
+      </p:sp>
+      <p:sp>
+        <p:nvSpPr>
+          <p:cNvPr id="69" name="Shape 67"/>
+          <p:cNvSpPr/>
+          <p:nvPr/>
+        </p:nvSpPr>
+        <p:spPr>
+          <a:xfrm>
+            <a:off x="3566160" y="4841748"/>
+            <a:ext cx="50292" cy="50292"/>
+          </a:xfrm>
+          <a:prstGeom prst="rect">
+            <a:avLst/>
+          </a:prstGeom>
+          <a:solidFill>
+            <a:srgbClr val="1F2A4A"/>
+          </a:solidFill>
+          <a:ln/>
+        </p:spPr>
+      </p:sp>
+      <p:sp>
+        <p:nvSpPr>
           <p:cNvPr id="70" name="Shape 68"/>
           <p:cNvSpPr/>
           <p:nvPr/>
         </p:nvSpPr>
         <p:spPr>
           <a:xfrm>
-            <a:off x="3566160" y="4434840"/>
+            <a:off x="3973068" y="4841748"/>
             <a:ext cx="50292" cy="50292"/>
           </a:xfrm>
           <a:prstGeom prst="rect">
@@ -16061,67 +16020,7 @@
       </p:sp>
       <p:sp>
         <p:nvSpPr>
-          <p:cNvPr id="71" name="Shape 69"/>
-          <p:cNvSpPr/>
-          <p:nvPr/>
-        </p:nvSpPr>
-        <p:spPr>
-          <a:xfrm>
-            <a:off x="3973068" y="4434840"/>
-            <a:ext cx="50292" cy="50292"/>
-          </a:xfrm>
-          <a:prstGeom prst="rect">
-            <a:avLst/>
-          </a:prstGeom>
-          <a:solidFill>
-            <a:srgbClr val="1F2A4A"/>
-          </a:solidFill>
-          <a:ln/>
-        </p:spPr>
-      </p:sp>
-      <p:sp>
-        <p:nvSpPr>
-          <p:cNvPr id="72" name="Shape 70"/>
-          <p:cNvSpPr/>
-          <p:nvPr/>
-        </p:nvSpPr>
-        <p:spPr>
-          <a:xfrm>
-            <a:off x="3566160" y="4841748"/>
-            <a:ext cx="50292" cy="50292"/>
-          </a:xfrm>
-          <a:prstGeom prst="rect">
-            <a:avLst/>
-          </a:prstGeom>
-          <a:solidFill>
-            <a:srgbClr val="1F2A4A"/>
-          </a:solidFill>
-          <a:ln/>
-        </p:spPr>
-      </p:sp>
-      <p:sp>
-        <p:nvSpPr>
-          <p:cNvPr id="73" name="Shape 71"/>
-          <p:cNvSpPr/>
-          <p:nvPr/>
-        </p:nvSpPr>
-        <p:spPr>
-          <a:xfrm>
-            <a:off x="3973068" y="4841748"/>
-            <a:ext cx="50292" cy="50292"/>
-          </a:xfrm>
-          <a:prstGeom prst="rect">
-            <a:avLst/>
-          </a:prstGeom>
-          <a:solidFill>
-            <a:srgbClr val="1F2A4A"/>
-          </a:solidFill>
-          <a:ln/>
-        </p:spPr>
-      </p:sp>
-      <p:sp>
-        <p:nvSpPr>
-          <p:cNvPr id="74" name="Text 72"/>
+          <p:cNvPr id="71" name="Text 69"/>
           <p:cNvSpPr txBox="1"/>
           <p:nvPr/>
         </p:nvSpPr>
@@ -16160,7 +16059,7 @@
       </p:sp>
       <p:sp>
         <p:nvSpPr>
-          <p:cNvPr id="75" name="Text 73"/>
+          <p:cNvPr id="72" name="Text 70"/>
           <p:cNvSpPr txBox="1"/>
           <p:nvPr/>
         </p:nvSpPr>
@@ -16199,7 +16098,7 @@
       </p:sp>
       <p:sp>
         <p:nvSpPr>
-          <p:cNvPr id="76" name="Text 74"/>
+          <p:cNvPr id="73" name="Text 71"/>
           <p:cNvSpPr txBox="1"/>
           <p:nvPr/>
         </p:nvSpPr>
@@ -16230,7 +16129,7 @@
                 <a:ea typeface="맑은 고딕" pitchFamily="34" charset="-122"/>
                 <a:cs typeface="맑은 고딕" pitchFamily="34" charset="-120"/>
               </a:rPr>
-              <a:t>Unity 개발, 판정 엔진 (F2·F4)</a:t>
+              <a:t>기획·메인 개발(Unity)·테스트</a:t>
             </a:r>
             <a:endParaRPr lang="ko-KR" sz="1150" dirty="0"/>
           </a:p>
@@ -16238,7 +16137,7 @@
       </p:sp>
       <p:sp>
         <p:nvSpPr>
-          <p:cNvPr id="77" name="Shape 75"/>
+          <p:cNvPr id="74" name="Shape 72"/>
           <p:cNvSpPr/>
           <p:nvPr/>
         </p:nvSpPr>
@@ -16258,7 +16157,7 @@
       </p:sp>
       <p:sp>
         <p:nvSpPr>
-          <p:cNvPr id="78" name="Shape 76"/>
+          <p:cNvPr id="75" name="Shape 73"/>
           <p:cNvSpPr/>
           <p:nvPr/>
         </p:nvSpPr>
@@ -16278,13 +16177,73 @@
       </p:sp>
       <p:sp>
         <p:nvSpPr>
+          <p:cNvPr id="76" name="Shape 74"/>
+          <p:cNvSpPr/>
+          <p:nvPr/>
+        </p:nvSpPr>
+        <p:spPr>
+          <a:xfrm>
+            <a:off x="6181344" y="4251960"/>
+            <a:ext cx="50292" cy="50292"/>
+          </a:xfrm>
+          <a:prstGeom prst="rect">
+            <a:avLst/>
+          </a:prstGeom>
+          <a:solidFill>
+            <a:srgbClr val="0F1426"/>
+          </a:solidFill>
+          <a:ln/>
+        </p:spPr>
+      </p:sp>
+      <p:sp>
+        <p:nvSpPr>
+          <p:cNvPr id="77" name="Shape 75"/>
+          <p:cNvSpPr/>
+          <p:nvPr/>
+        </p:nvSpPr>
+        <p:spPr>
+          <a:xfrm>
+            <a:off x="8782812" y="4251960"/>
+            <a:ext cx="50292" cy="50292"/>
+          </a:xfrm>
+          <a:prstGeom prst="rect">
+            <a:avLst/>
+          </a:prstGeom>
+          <a:solidFill>
+            <a:srgbClr val="0F1426"/>
+          </a:solidFill>
+          <a:ln/>
+        </p:spPr>
+      </p:sp>
+      <p:sp>
+        <p:nvSpPr>
+          <p:cNvPr id="78" name="Shape 76"/>
+          <p:cNvSpPr/>
+          <p:nvPr/>
+        </p:nvSpPr>
+        <p:spPr>
+          <a:xfrm>
+            <a:off x="6181344" y="5436108"/>
+            <a:ext cx="50292" cy="50292"/>
+          </a:xfrm>
+          <a:prstGeom prst="rect">
+            <a:avLst/>
+          </a:prstGeom>
+          <a:solidFill>
+            <a:srgbClr val="0F1426"/>
+          </a:solidFill>
+          <a:ln/>
+        </p:spPr>
+      </p:sp>
+      <p:sp>
+        <p:nvSpPr>
           <p:cNvPr id="79" name="Shape 77"/>
           <p:cNvSpPr/>
           <p:nvPr/>
         </p:nvSpPr>
         <p:spPr>
           <a:xfrm>
-            <a:off x="6181344" y="4251960"/>
+            <a:off x="8782812" y="5436108"/>
             <a:ext cx="50292" cy="50292"/>
           </a:xfrm>
           <a:prstGeom prst="rect">
@@ -16299,66 +16258,6 @@
       <p:sp>
         <p:nvSpPr>
           <p:cNvPr id="80" name="Shape 78"/>
-          <p:cNvSpPr/>
-          <p:nvPr/>
-        </p:nvSpPr>
-        <p:spPr>
-          <a:xfrm>
-            <a:off x="8782812" y="4251960"/>
-            <a:ext cx="50292" cy="50292"/>
-          </a:xfrm>
-          <a:prstGeom prst="rect">
-            <a:avLst/>
-          </a:prstGeom>
-          <a:solidFill>
-            <a:srgbClr val="0F1426"/>
-          </a:solidFill>
-          <a:ln/>
-        </p:spPr>
-      </p:sp>
-      <p:sp>
-        <p:nvSpPr>
-          <p:cNvPr id="81" name="Shape 79"/>
-          <p:cNvSpPr/>
-          <p:nvPr/>
-        </p:nvSpPr>
-        <p:spPr>
-          <a:xfrm>
-            <a:off x="6181344" y="5436108"/>
-            <a:ext cx="50292" cy="50292"/>
-          </a:xfrm>
-          <a:prstGeom prst="rect">
-            <a:avLst/>
-          </a:prstGeom>
-          <a:solidFill>
-            <a:srgbClr val="0F1426"/>
-          </a:solidFill>
-          <a:ln/>
-        </p:spPr>
-      </p:sp>
-      <p:sp>
-        <p:nvSpPr>
-          <p:cNvPr id="82" name="Shape 80"/>
-          <p:cNvSpPr/>
-          <p:nvPr/>
-        </p:nvSpPr>
-        <p:spPr>
-          <a:xfrm>
-            <a:off x="8782812" y="5436108"/>
-            <a:ext cx="50292" cy="50292"/>
-          </a:xfrm>
-          <a:prstGeom prst="rect">
-            <a:avLst/>
-          </a:prstGeom>
-          <a:solidFill>
-            <a:srgbClr val="0F1426"/>
-          </a:solidFill>
-          <a:ln/>
-        </p:spPr>
-      </p:sp>
-      <p:sp>
-        <p:nvSpPr>
-          <p:cNvPr id="83" name="Shape 81"/>
           <p:cNvSpPr/>
           <p:nvPr/>
         </p:nvSpPr>
@@ -16378,7 +16277,7 @@
       </p:sp>
       <p:sp>
         <p:nvSpPr>
-          <p:cNvPr id="84" name="Shape 82"/>
+          <p:cNvPr id="81" name="Shape 79"/>
           <p:cNvSpPr/>
           <p:nvPr/>
         </p:nvSpPr>
@@ -16398,13 +16297,73 @@
       </p:sp>
       <p:sp>
         <p:nvSpPr>
+          <p:cNvPr id="82" name="Shape 80"/>
+          <p:cNvSpPr/>
+          <p:nvPr/>
+        </p:nvSpPr>
+        <p:spPr>
+          <a:xfrm>
+            <a:off x="6382512" y="4434840"/>
+            <a:ext cx="50292" cy="50292"/>
+          </a:xfrm>
+          <a:prstGeom prst="rect">
+            <a:avLst/>
+          </a:prstGeom>
+          <a:solidFill>
+            <a:srgbClr val="1F2A4A"/>
+          </a:solidFill>
+          <a:ln/>
+        </p:spPr>
+      </p:sp>
+      <p:sp>
+        <p:nvSpPr>
+          <p:cNvPr id="83" name="Shape 81"/>
+          <p:cNvSpPr/>
+          <p:nvPr/>
+        </p:nvSpPr>
+        <p:spPr>
+          <a:xfrm>
+            <a:off x="6789420" y="4434840"/>
+            <a:ext cx="50292" cy="50292"/>
+          </a:xfrm>
+          <a:prstGeom prst="rect">
+            <a:avLst/>
+          </a:prstGeom>
+          <a:solidFill>
+            <a:srgbClr val="1F2A4A"/>
+          </a:solidFill>
+          <a:ln/>
+        </p:spPr>
+      </p:sp>
+      <p:sp>
+        <p:nvSpPr>
+          <p:cNvPr id="84" name="Shape 82"/>
+          <p:cNvSpPr/>
+          <p:nvPr/>
+        </p:nvSpPr>
+        <p:spPr>
+          <a:xfrm>
+            <a:off x="6382512" y="4841748"/>
+            <a:ext cx="50292" cy="50292"/>
+          </a:xfrm>
+          <a:prstGeom prst="rect">
+            <a:avLst/>
+          </a:prstGeom>
+          <a:solidFill>
+            <a:srgbClr val="1F2A4A"/>
+          </a:solidFill>
+          <a:ln/>
+        </p:spPr>
+      </p:sp>
+      <p:sp>
+        <p:nvSpPr>
           <p:cNvPr id="85" name="Shape 83"/>
           <p:cNvSpPr/>
           <p:nvPr/>
         </p:nvSpPr>
         <p:spPr>
           <a:xfrm>
-            <a:off x="6382512" y="4434840"/>
+            <a:off x="6789420" y="4841748"/>
             <a:ext cx="50292" cy="50292"/>
           </a:xfrm>
           <a:prstGeom prst="rect">
@@ -16418,67 +16377,7 @@
       </p:sp>
       <p:sp>
         <p:nvSpPr>
-          <p:cNvPr id="86" name="Shape 84"/>
-          <p:cNvSpPr/>
-          <p:nvPr/>
-        </p:nvSpPr>
-        <p:spPr>
-          <a:xfrm>
-            <a:off x="6789420" y="4434840"/>
-            <a:ext cx="50292" cy="50292"/>
-          </a:xfrm>
-          <a:prstGeom prst="rect">
-            <a:avLst/>
-          </a:prstGeom>
-          <a:solidFill>
-            <a:srgbClr val="1F2A4A"/>
-          </a:solidFill>
-          <a:ln/>
-        </p:spPr>
-      </p:sp>
-      <p:sp>
-        <p:nvSpPr>
-          <p:cNvPr id="87" name="Shape 85"/>
-          <p:cNvSpPr/>
-          <p:nvPr/>
-        </p:nvSpPr>
-        <p:spPr>
-          <a:xfrm>
-            <a:off x="6382512" y="4841748"/>
-            <a:ext cx="50292" cy="50292"/>
-          </a:xfrm>
-          <a:prstGeom prst="rect">
-            <a:avLst/>
-          </a:prstGeom>
-          <a:solidFill>
-            <a:srgbClr val="1F2A4A"/>
-          </a:solidFill>
-          <a:ln/>
-        </p:spPr>
-      </p:sp>
-      <p:sp>
-        <p:nvSpPr>
-          <p:cNvPr id="88" name="Shape 86"/>
-          <p:cNvSpPr/>
-          <p:nvPr/>
-        </p:nvSpPr>
-        <p:spPr>
-          <a:xfrm>
-            <a:off x="6789420" y="4841748"/>
-            <a:ext cx="50292" cy="50292"/>
-          </a:xfrm>
-          <a:prstGeom prst="rect">
-            <a:avLst/>
-          </a:prstGeom>
-          <a:solidFill>
-            <a:srgbClr val="1F2A4A"/>
-          </a:solidFill>
-          <a:ln/>
-        </p:spPr>
-      </p:sp>
-      <p:sp>
-        <p:nvSpPr>
-          <p:cNvPr id="89" name="Text 87"/>
+          <p:cNvPr id="86" name="Text 84"/>
           <p:cNvSpPr txBox="1"/>
           <p:nvPr/>
         </p:nvSpPr>
@@ -16517,7 +16416,7 @@
       </p:sp>
       <p:sp>
         <p:nvSpPr>
-          <p:cNvPr id="90" name="Text 88"/>
+          <p:cNvPr id="87" name="Text 85"/>
           <p:cNvSpPr txBox="1"/>
           <p:nvPr/>
         </p:nvSpPr>
@@ -16556,7 +16455,7 @@
       </p:sp>
       <p:sp>
         <p:nvSpPr>
-          <p:cNvPr id="91" name="Text 89"/>
+          <p:cNvPr id="88" name="Text 86"/>
           <p:cNvSpPr txBox="1"/>
           <p:nvPr/>
         </p:nvSpPr>
@@ -16587,7 +16486,7 @@
                 <a:ea typeface="맑은 고딕" pitchFamily="34" charset="-122"/>
                 <a:cs typeface="맑은 고딕" pitchFamily="34" charset="-120"/>
               </a:rPr>
-              <a:t>도트 그래픽·화면 디자인</a:t>
+              <a:t>기획·자료 수집·디자인·사례 개발</a:t>
             </a:r>
             <a:endParaRPr lang="ko-KR" sz="1150" dirty="0"/>
           </a:p>
@@ -16595,7 +16494,7 @@
       </p:sp>
       <p:sp>
         <p:nvSpPr>
-          <p:cNvPr id="92" name="Shape 90"/>
+          <p:cNvPr id="89" name="Shape 87"/>
           <p:cNvSpPr/>
           <p:nvPr/>
         </p:nvSpPr>
@@ -16615,7 +16514,7 @@
       </p:sp>
       <p:sp>
         <p:nvSpPr>
-          <p:cNvPr id="93" name="Shape 91"/>
+          <p:cNvPr id="90" name="Shape 88"/>
           <p:cNvSpPr/>
           <p:nvPr/>
         </p:nvSpPr>
@@ -16635,13 +16534,73 @@
       </p:sp>
       <p:sp>
         <p:nvSpPr>
+          <p:cNvPr id="91" name="Shape 89"/>
+          <p:cNvSpPr/>
+          <p:nvPr/>
+        </p:nvSpPr>
+        <p:spPr>
+          <a:xfrm>
+            <a:off x="8997696" y="4251960"/>
+            <a:ext cx="50292" cy="50292"/>
+          </a:xfrm>
+          <a:prstGeom prst="rect">
+            <a:avLst/>
+          </a:prstGeom>
+          <a:solidFill>
+            <a:srgbClr val="0F1426"/>
+          </a:solidFill>
+          <a:ln/>
+        </p:spPr>
+      </p:sp>
+      <p:sp>
+        <p:nvSpPr>
+          <p:cNvPr id="92" name="Shape 90"/>
+          <p:cNvSpPr/>
+          <p:nvPr/>
+        </p:nvSpPr>
+        <p:spPr>
+          <a:xfrm>
+            <a:off x="11599164" y="4251960"/>
+            <a:ext cx="50292" cy="50292"/>
+          </a:xfrm>
+          <a:prstGeom prst="rect">
+            <a:avLst/>
+          </a:prstGeom>
+          <a:solidFill>
+            <a:srgbClr val="0F1426"/>
+          </a:solidFill>
+          <a:ln/>
+        </p:spPr>
+      </p:sp>
+      <p:sp>
+        <p:nvSpPr>
+          <p:cNvPr id="93" name="Shape 91"/>
+          <p:cNvSpPr/>
+          <p:nvPr/>
+        </p:nvSpPr>
+        <p:spPr>
+          <a:xfrm>
+            <a:off x="8997696" y="5436108"/>
+            <a:ext cx="50292" cy="50292"/>
+          </a:xfrm>
+          <a:prstGeom prst="rect">
+            <a:avLst/>
+          </a:prstGeom>
+          <a:solidFill>
+            <a:srgbClr val="0F1426"/>
+          </a:solidFill>
+          <a:ln/>
+        </p:spPr>
+      </p:sp>
+      <p:sp>
+        <p:nvSpPr>
           <p:cNvPr id="94" name="Shape 92"/>
           <p:cNvSpPr/>
           <p:nvPr/>
         </p:nvSpPr>
         <p:spPr>
           <a:xfrm>
-            <a:off x="8997696" y="4251960"/>
+            <a:off x="11599164" y="5436108"/>
             <a:ext cx="50292" cy="50292"/>
           </a:xfrm>
           <a:prstGeom prst="rect">
@@ -16656,66 +16615,6 @@
       <p:sp>
         <p:nvSpPr>
           <p:cNvPr id="95" name="Shape 93"/>
-          <p:cNvSpPr/>
-          <p:nvPr/>
-        </p:nvSpPr>
-        <p:spPr>
-          <a:xfrm>
-            <a:off x="11599164" y="4251960"/>
-            <a:ext cx="50292" cy="50292"/>
-          </a:xfrm>
-          <a:prstGeom prst="rect">
-            <a:avLst/>
-          </a:prstGeom>
-          <a:solidFill>
-            <a:srgbClr val="0F1426"/>
-          </a:solidFill>
-          <a:ln/>
-        </p:spPr>
-      </p:sp>
-      <p:sp>
-        <p:nvSpPr>
-          <p:cNvPr id="96" name="Shape 94"/>
-          <p:cNvSpPr/>
-          <p:nvPr/>
-        </p:nvSpPr>
-        <p:spPr>
-          <a:xfrm>
-            <a:off x="8997696" y="5436108"/>
-            <a:ext cx="50292" cy="50292"/>
-          </a:xfrm>
-          <a:prstGeom prst="rect">
-            <a:avLst/>
-          </a:prstGeom>
-          <a:solidFill>
-            <a:srgbClr val="0F1426"/>
-          </a:solidFill>
-          <a:ln/>
-        </p:spPr>
-      </p:sp>
-      <p:sp>
-        <p:nvSpPr>
-          <p:cNvPr id="97" name="Shape 95"/>
-          <p:cNvSpPr/>
-          <p:nvPr/>
-        </p:nvSpPr>
-        <p:spPr>
-          <a:xfrm>
-            <a:off x="11599164" y="5436108"/>
-            <a:ext cx="50292" cy="50292"/>
-          </a:xfrm>
-          <a:prstGeom prst="rect">
-            <a:avLst/>
-          </a:prstGeom>
-          <a:solidFill>
-            <a:srgbClr val="0F1426"/>
-          </a:solidFill>
-          <a:ln/>
-        </p:spPr>
-      </p:sp>
-      <p:sp>
-        <p:nvSpPr>
-          <p:cNvPr id="98" name="Shape 96"/>
           <p:cNvSpPr/>
           <p:nvPr/>
         </p:nvSpPr>
@@ -16735,7 +16634,7 @@
       </p:sp>
       <p:sp>
         <p:nvSpPr>
-          <p:cNvPr id="99" name="Shape 97"/>
+          <p:cNvPr id="96" name="Shape 94"/>
           <p:cNvSpPr/>
           <p:nvPr/>
         </p:nvSpPr>
@@ -16755,13 +16654,73 @@
       </p:sp>
       <p:sp>
         <p:nvSpPr>
+          <p:cNvPr id="97" name="Shape 95"/>
+          <p:cNvSpPr/>
+          <p:nvPr/>
+        </p:nvSpPr>
+        <p:spPr>
+          <a:xfrm>
+            <a:off x="9198864" y="4434840"/>
+            <a:ext cx="50292" cy="50292"/>
+          </a:xfrm>
+          <a:prstGeom prst="rect">
+            <a:avLst/>
+          </a:prstGeom>
+          <a:solidFill>
+            <a:srgbClr val="1F2A4A"/>
+          </a:solidFill>
+          <a:ln/>
+        </p:spPr>
+      </p:sp>
+      <p:sp>
+        <p:nvSpPr>
+          <p:cNvPr id="98" name="Shape 96"/>
+          <p:cNvSpPr/>
+          <p:nvPr/>
+        </p:nvSpPr>
+        <p:spPr>
+          <a:xfrm>
+            <a:off x="9605772" y="4434840"/>
+            <a:ext cx="50292" cy="50292"/>
+          </a:xfrm>
+          <a:prstGeom prst="rect">
+            <a:avLst/>
+          </a:prstGeom>
+          <a:solidFill>
+            <a:srgbClr val="1F2A4A"/>
+          </a:solidFill>
+          <a:ln/>
+        </p:spPr>
+      </p:sp>
+      <p:sp>
+        <p:nvSpPr>
+          <p:cNvPr id="99" name="Shape 97"/>
+          <p:cNvSpPr/>
+          <p:nvPr/>
+        </p:nvSpPr>
+        <p:spPr>
+          <a:xfrm>
+            <a:off x="9198864" y="4841748"/>
+            <a:ext cx="50292" cy="50292"/>
+          </a:xfrm>
+          <a:prstGeom prst="rect">
+            <a:avLst/>
+          </a:prstGeom>
+          <a:solidFill>
+            <a:srgbClr val="1F2A4A"/>
+          </a:solidFill>
+          <a:ln/>
+        </p:spPr>
+      </p:sp>
+      <p:sp>
+        <p:nvSpPr>
           <p:cNvPr id="100" name="Shape 98"/>
           <p:cNvSpPr/>
           <p:nvPr/>
         </p:nvSpPr>
         <p:spPr>
           <a:xfrm>
-            <a:off x="9198864" y="4434840"/>
+            <a:off x="9605772" y="4841748"/>
             <a:ext cx="50292" cy="50292"/>
           </a:xfrm>
           <a:prstGeom prst="rect">
@@ -16775,67 +16734,7 @@
       </p:sp>
       <p:sp>
         <p:nvSpPr>
-          <p:cNvPr id="101" name="Shape 99"/>
-          <p:cNvSpPr/>
-          <p:nvPr/>
-        </p:nvSpPr>
-        <p:spPr>
-          <a:xfrm>
-            <a:off x="9605772" y="4434840"/>
-            <a:ext cx="50292" cy="50292"/>
-          </a:xfrm>
-          <a:prstGeom prst="rect">
-            <a:avLst/>
-          </a:prstGeom>
-          <a:solidFill>
-            <a:srgbClr val="1F2A4A"/>
-          </a:solidFill>
-          <a:ln/>
-        </p:spPr>
-      </p:sp>
-      <p:sp>
-        <p:nvSpPr>
-          <p:cNvPr id="102" name="Shape 100"/>
-          <p:cNvSpPr/>
-          <p:nvPr/>
-        </p:nvSpPr>
-        <p:spPr>
-          <a:xfrm>
-            <a:off x="9198864" y="4841748"/>
-            <a:ext cx="50292" cy="50292"/>
-          </a:xfrm>
-          <a:prstGeom prst="rect">
-            <a:avLst/>
-          </a:prstGeom>
-          <a:solidFill>
-            <a:srgbClr val="1F2A4A"/>
-          </a:solidFill>
-          <a:ln/>
-        </p:spPr>
-      </p:sp>
-      <p:sp>
-        <p:nvSpPr>
-          <p:cNvPr id="103" name="Shape 101"/>
-          <p:cNvSpPr/>
-          <p:nvPr/>
-        </p:nvSpPr>
-        <p:spPr>
-          <a:xfrm>
-            <a:off x="9605772" y="4841748"/>
-            <a:ext cx="50292" cy="50292"/>
-          </a:xfrm>
-          <a:prstGeom prst="rect">
-            <a:avLst/>
-          </a:prstGeom>
-          <a:solidFill>
-            <a:srgbClr val="1F2A4A"/>
-          </a:solidFill>
-          <a:ln/>
-        </p:spPr>
-      </p:sp>
-      <p:sp>
-        <p:nvSpPr>
-          <p:cNvPr id="104" name="Text 102"/>
+          <p:cNvPr id="101" name="Text 99"/>
           <p:cNvSpPr txBox="1"/>
           <p:nvPr/>
         </p:nvSpPr>
@@ -16874,7 +16773,7 @@
       </p:sp>
       <p:sp>
         <p:nvSpPr>
-          <p:cNvPr id="105" name="Text 103"/>
+          <p:cNvPr id="102" name="Text 100"/>
           <p:cNvSpPr txBox="1"/>
           <p:nvPr/>
         </p:nvSpPr>
@@ -16913,7 +16812,7 @@
       </p:sp>
       <p:sp>
         <p:nvSpPr>
-          <p:cNvPr id="106" name="Text 104"/>
+          <p:cNvPr id="103" name="Text 101"/>
           <p:cNvSpPr txBox="1"/>
           <p:nvPr/>
         </p:nvSpPr>
@@ -16944,7 +16843,7 @@
                 <a:ea typeface="맑은 고딕" pitchFamily="34" charset="-122"/>
                 <a:cs typeface="맑은 고딕" pitchFamily="34" charset="-120"/>
               </a:rPr>
-              <a:t>테스트·접근성 (글자 크기·모드)</a:t>
+              <a:t>기획·자료 수집·디자인·보고서</a:t>
             </a:r>
             <a:endParaRPr lang="ko-KR" sz="1150" dirty="0"/>
           </a:p>
@@ -16952,7 +16851,7 @@
       </p:sp>
       <p:sp>
         <p:nvSpPr>
-          <p:cNvPr id="107" name="Text 105"/>
+          <p:cNvPr id="104" name="Text 102"/>
           <p:cNvSpPr txBox="1"/>
           <p:nvPr/>
         </p:nvSpPr>
@@ -16983,7 +16882,7 @@
                 <a:ea typeface="Galmuri11" pitchFamily="34" charset="-122"/>
                 <a:cs typeface="Galmuri11" pitchFamily="34" charset="-120"/>
               </a:rPr>
-              <a:t>※ 월별 일정과 역할은 팀 상황에 맞게 고쳐 쓰는 칸입니다.</a:t>
+              <a:t>※ 일정과 역할은 과제 계획서(2026.09~12, 4명)를 따르고, 작업 내용은 현재 기획(v0.3)에 맞췄습니다.</a:t>
             </a:r>
             <a:endParaRPr lang="ko-KR" sz="1100" dirty="0"/>
           </a:p>
@@ -17935,7 +17834,7 @@
                 <a:ea typeface="맑은 고딕" pitchFamily="34" charset="-122"/>
                 <a:cs typeface="맑은 고딕" pitchFamily="34" charset="-120"/>
               </a:rPr>
-              <a:t>사례 14개·화면 10개,</a:t>
+              <a:t>이번 학기 안에 Unity</a:t>
             </a:r>
             <a:endParaRPr lang="ko-KR" sz="1500" dirty="0"/>
           </a:p>
@@ -17955,7 +17854,7 @@
                 <a:ea typeface="맑은 고딕" pitchFamily="34" charset="-122"/>
                 <a:cs typeface="맑은 고딕" pitchFamily="34" charset="-120"/>
               </a:rPr>
-              <a:t>다음 학기에 다 만들 수 있을까?</a:t>
+              <a:t>프로토타입까지 갈 수 있을까?</a:t>
             </a:r>
             <a:endParaRPr lang="ko-KR" sz="1500" dirty="0"/>
           </a:p>
@@ -17997,7 +17896,7 @@
                 <a:ea typeface="맑은 고딕" pitchFamily="34" charset="-122"/>
                 <a:cs typeface="맑은 고딕" pitchFamily="34" charset="-120"/>
               </a:rPr>
-              <a:t>→ 판정 규칙을 데이터로 분리했어요. 범위가 적절한지 의견 부탁드립니다</a:t>
+              <a:t>→ 판정 규칙을 데이터로 분리해 하루치 사례부터 만들어요. 범위가 적절한지 의견 부탁드립니다</a:t>
             </a:r>
             <a:endParaRPr lang="ko-KR" sz="1200" dirty="0"/>
           </a:p>
@@ -18263,7 +18162,7 @@
                 <a:ea typeface="Galmuri11" pitchFamily="34" charset="-122"/>
                 <a:cs typeface="Galmuri11" pitchFamily="34" charset="-120"/>
               </a:rPr>
-              <a:t>Team ________  |  DIGITAL GUARD (가칭)</a:t>
+              <a:t>Team 셜록홈즈  |  DIGITAL GUARD (가칭)</a:t>
             </a:r>
             <a:endParaRPr lang="ko-KR" sz="1300" dirty="0"/>
           </a:p>
@@ -19864,7 +19763,7 @@
                 <a:ea typeface="맑은 고딕" pitchFamily="34" charset="-122"/>
                 <a:cs typeface="맑은 고딕" pitchFamily="34" charset="-120"/>
               </a:rPr>
-              <a:t>"조심하세요"라는 말은 많지만,</a:t>
+              <a:t>강의·포스터 위주의 교육은</a:t>
             </a:r>
             <a:endParaRPr lang="ko-KR" sz="1500" dirty="0"/>
           </a:p>
@@ -19884,7 +19783,7 @@
                 <a:ea typeface="맑은 고딕" pitchFamily="34" charset="-122"/>
                 <a:cs typeface="맑은 고딕" pitchFamily="34" charset="-120"/>
               </a:rPr>
-              <a:t>직접 비교해 보고 확인하는</a:t>
+              <a:t>직접 비교하고 판단해 보는</a:t>
             </a:r>
             <a:endParaRPr lang="ko-KR" sz="1500" dirty="0"/>
           </a:p>
@@ -19904,7 +19803,7 @@
                 <a:ea typeface="맑은 고딕" pitchFamily="34" charset="-122"/>
                 <a:cs typeface="맑은 고딕" pitchFamily="34" charset="-120"/>
               </a:rPr>
-              <a:t>연습을 할 곳은 많지 않아요.</a:t>
+              <a:t>경험으로 이어지기 어려워요.</a:t>
             </a:r>
             <a:endParaRPr lang="ko-KR" sz="1500" dirty="0"/>
           </a:p>
@@ -22068,7 +21967,46 @@
         </p:nvSpPr>
         <p:spPr>
           <a:xfrm>
-            <a:off x="548640" y="5760720"/>
+            <a:off x="548640" y="5669280"/>
+            <a:ext cx="11064240" cy="256032"/>
+          </a:xfrm>
+          <a:prstGeom prst="rect">
+            <a:avLst/>
+          </a:prstGeom>
+          <a:noFill/>
+          <a:ln/>
+        </p:spPr>
+        <p:txBody>
+          <a:bodyPr wrap="square" lIns="0" tIns="0" rIns="0" bIns="0" rtlCol="0" anchor="t"/>
+          <a:lstStyle/>
+          <a:p>
+            <a:pPr indent="0" marL="0">
+              <a:buNone/>
+            </a:pPr>
+            <a:r>
+              <a:rPr lang="ko-KR" altLang="en-US" sz="1100" dirty="0">
+                <a:solidFill>
+                  <a:srgbClr val="FFFFFF"/>
+                </a:solidFill>
+                <a:latin typeface="Galmuri11" pitchFamily="34" charset="0"/>
+                <a:ea typeface="Galmuri11" pitchFamily="34" charset="-122"/>
+                <a:cs typeface="Galmuri11" pitchFamily="34" charset="-120"/>
+              </a:rPr>
+              <a:t>KISA 스미싱 문자 탐지 건수: 2022년 3만 7,122건 → 2023년 50만 3,300건 → 2024년 219만 6,469건 (한국인터넷진흥원, 국정감사 제출자료, 2024)</a:t>
+            </a:r>
+            <a:endParaRPr lang="ko-KR" sz="1100" dirty="0"/>
+          </a:p>
+        </p:txBody>
+      </p:sp>
+      <p:sp>
+        <p:nvSpPr>
+          <p:cNvPr id="84" name="Text 74"/>
+          <p:cNvSpPr txBox="1"/>
+          <p:nvPr/>
+        </p:nvSpPr>
+        <p:spPr>
+          <a:xfrm>
+            <a:off x="548640" y="5961888"/>
             <a:ext cx="10972800" cy="256032"/>
           </a:xfrm>
           <a:prstGeom prst="rect">

</xml_diff>

<commit_message>
Shift mid-term deck framing from education to gameplay
Cover and intro now present it as an all-ages deduction puzzle game;
the teacher/librarian persona is replaced by a young-adult player, and
"why needed" becomes "what makes it fun".

Co-Authored-By: Claude Opus 5.5 <noreply@anthropic.com>
Claude-Session: https://claude.ai/code/session_016TK7RStkSbtFST378Masih
</commit_message>
<xml_diff>
--- a/docs/digital-guard/presentation/DIGITAL_GUARD_중간설계발표.pptx
+++ b/docs/digital-guard/presentation/DIGITAL_GUARD_중간설계발표.pptx
@@ -120,24 +120,24 @@
   <p:extLst>
     <p:ext uri="{521415D9-36F7-43E2-AB2F-B90AF26B5E84}">
       <p14:sectionLst xmlns:p14="http://schemas.microsoft.com/office/powerpoint/2010/main">
-        <p14:section name="표지" id="{64a6a486-66de-3513-c182-dd88d9235a62}">
+        <p14:section name="표지" id="{63b17084-fc5b-653b-953b-f9e9ade2343b}">
           <p14:sldIdLst>
             <p14:sldId id="256"/>
           </p14:sldIdLst>
         </p14:section>
-        <p14:section name="01 게임 소개" id="{97374177-f983-099c-b17c-07588c42b8b9}">
+        <p14:section name="01 게임 소개" id="{c59228a3-37a1-0c86-7f20-6f1097fa2caf}">
           <p14:sldIdLst>
             <p14:sldId id="257"/>
             <p14:sldId id="258"/>
             <p14:sldId id="259"/>
           </p14:sldIdLst>
         </p14:section>
-        <p14:section name="02 핵심 기능" id="{d05fb2b0-8baf-02ba-aa7d-830c23dbf50a}">
+        <p14:section name="02 핵심 기능" id="{1d23a183-f938-a378-dbc8-17049190b804}">
           <p14:sldIdLst>
             <p14:sldId id="260"/>
           </p14:sldIdLst>
         </p14:section>
-        <p14:section name="03 화면 설계" id="{8b54013c-aeed-8a27-a9f0-55cedd3c98d1}">
+        <p14:section name="03 화면 설계" id="{855cdcb9-adc0-1f3a-6bb3-b24c160b5a1c}">
           <p14:sldIdLst>
             <p14:sldId id="261"/>
             <p14:sldId id="262"/>
@@ -147,13 +147,13 @@
             <p14:sldId id="266"/>
           </p14:sldIdLst>
         </p14:section>
-        <p14:section name="04 점검 · 계획" id="{ed7d5865-897a-e8fe-85f2-810fa395d303}">
+        <p14:section name="04 점검 · 계획" id="{2ca90cca-ccc5-679b-2d03-29908f9dead2}">
           <p14:sldIdLst>
             <p14:sldId id="267"/>
             <p14:sldId id="268"/>
           </p14:sldIdLst>
         </p14:section>
-        <p14:section name="마무리" id="{e97e6fa0-a0f4-fdb5-2484-a0999fdec1c4}">
+        <p14:section name="마무리" id="{48b4bfad-0b44-3cc9-5f03-256cd12f1bea}">
           <p14:sldIdLst>
             <p14:sldId id="269"/>
           </p14:sldIdLst>
@@ -562,7 +562,7 @@
           <a:p>
             <a:r>
               <a:rPr lang="en-US" dirty="0"/>
-              <a:t>안녕하세요, 팀 셜록홈즈입니다. 저희는 수상한 문자·파일·로그인 요청을 서류처럼 대조해서 가려내는 전연령 디지털 안전 퍼즐 게임, DIGITAL GUARD를 기획하고 있습니다. 이름은 아직 가칭입니다. 오늘은 무엇을 만드는지, 그리고 어떤 화면으로 동작하는지를 중심으로 말씀드리겠습니다.</a:t>
+              <a:t>안녕하세요, 팀 셜록홈즈입니다. 저희는 수상한 문자·파일·로그인 요청을 서류처럼 대조해서 가려내는 전연령 추리 퍼즐 게임, DIGITAL GUARD를 기획하고 있습니다. 이름은 아직 가칭입니다. 오늘은 무엇을 만드는지, 그리고 어떤 화면으로 동작하는지를 중심으로 말씀드리겠습니다.</a:t>
             </a:r>
             <a:endParaRPr lang="en-US" dirty="0"/>
           </a:p>
@@ -826,7 +826,7 @@
           <a:p>
             <a:r>
               <a:rPr lang="en-US" dirty="0"/>
-              <a:t>지금까지 보여 드린 기능을 표로 점검했습니다. 꼭 만들 기능 다섯 개는 HTML 시제품에서 하루치 흐름이 동작하는 것까지 확인했습니다. 보안 사전과 복습 노트, 밝은 모던 테마, 센터 꾸미기는 시간이 남으면 추가합니다. 광고와 결제, 온라인 순위와 계정, 실제 기관이나 인물 자료는 이번 프로젝트에서 만들지 않습니다. 과제 계획서에서는 서버 계정과 랭킹을 계획했지만, 어린이와 어르신이 함께 쓰는 교육용 게임이라 개인정보를 받지 않는 오프라인 방식으로 바꾸고, 진행은 기기 안에 저장하기로 했습니다.</a:t>
+              <a:t>지금까지 보여 드린 기능을 표로 점검했습니다. 꼭 만들 기능 다섯 개는 HTML 시제품에서 하루치 흐름이 동작하는 것까지 확인했습니다. 보안 사전과 복습 노트, 밝은 모던 테마, 센터 꾸미기는 시간이 남으면 추가합니다. 광고와 결제, 온라인 순위와 계정, 실제 기관이나 인물 자료는 이번 프로젝트에서 만들지 않습니다. 과제 계획서에서는 서버 계정과 랭킹을 계획했지만, 어린이부터 어르신까지 가입 없이 바로 할 수 있도록 개인정보를 받지 않는 오프라인 방식으로 바꾸고, 진행은 기기 안에 저장하기로 했습니다.</a:t>
             </a:r>
             <a:endParaRPr lang="en-US" dirty="0"/>
           </a:p>
@@ -1090,7 +1090,7 @@
           <a:p>
             <a:r>
               <a:rPr lang="en-US" dirty="0"/>
-              <a:t>DIGITAL GUARD를 한 문장으로 말하면, 수상한 문자나 파일, 로그인 요청을 내 기록이나 공식 자료와 대조해서 승인할지, 거부할지, 추가로 확인할지를 판정하는 전연령 퍼즐 게임입니다. 스마트폰을 쓰는 누구나 대상이고, 하루 한 판은 10~15분 정도입니다. 지금의 보안 교육은 강의나 포스터 위주라서, 실제 상황에서 직접 비교하고 판단해 보는 경험으로 이어지기 어렵다는 점에서 출발했습니다.</a:t>
+              <a:t>DIGITAL GUARD를 한 문장으로 말하면, 수상한 문자나 파일, 로그인 요청을 내 기록이나 공식 자료와 대조해서 승인할지, 거부할지, 추가로 확인할지를 판정하는 전연령 퍼즐 게임입니다. 스마트폰을 쓰는 누구나 대상이고, 하루 한 판은 10~15분 정도입니다. 재미의 중심은 서류 속 작은 차이를 찾아내는 추리입니다. 날마다 규칙이 늘고 사건이 점점 교묘해져서, 같은 방식만으로는 풀리지 않게 만들었습니다.</a:t>
             </a:r>
             <a:endParaRPr lang="en-US" dirty="0"/>
           </a:p>
@@ -1178,7 +1178,7 @@
           <a:p>
             <a:r>
               <a:rPr lang="en-US" dirty="0"/>
-              <a:t>회사원 하늘 씨의 점심시간을 예로 들어 보겠습니다. 주소 불명 택배 문자를 받고, 바빠서 링크부터 누른 뒤 이름과 주소를 입력했습니다. 저녁에 쇼핑 앱을 보니 기다리는 택배가 없었습니다. 링크 주소와 공식 주소, 그리고 내 주문 내역. 이 두 가지만 비교했어도 알아챌 수 있었습니다. 문제는 이런 비교 습관을 미리 연습할 곳이 없다는 점이고, 이 장면은 실제로 게임의 첫 사건이 됩니다. 한국인터넷진흥원 자료에 따르면 스미싱 문자 탐지 건수는 2022년 3만 7천여 건에서 2024년 219만 건으로 늘었습니다.</a:t>
+              <a:t>회사원 하늘 씨의 점심시간을 예로 들어 보겠습니다. 주소 불명 택배 문자를 받고, 바빠서 링크부터 누른 뒤 이름과 주소를 입력했습니다. 저녁에 쇼핑 앱을 보니 기다리는 택배가 없었습니다. 링크 주소와 공식 주소, 그리고 내 주문 내역. 이 두 가지만 비교했어도 알아챌 수 있었습니다. 저희는 이 비교해서 가려내는 과정 자체를 퍼즐로 만들었고, 이 장면은 실제로 게임의 첫 사건이 됩니다. 한국인터넷진흥원 자료에 따르면 스미싱 문자 탐지 건수는 2022년 3만 7천여 건에서 2024년 219만 건으로 늘었습니다.</a:t>
             </a:r>
             <a:endParaRPr lang="en-US" dirty="0"/>
           </a:p>
@@ -1266,7 +1266,7 @@
           <a:p>
             <a:r>
               <a:rPr lang="en-US" dirty="0"/>
-              <a:t>플레이어는 크게 세 부류입니다. 링크를 쉽게 누르는 어린이·청소년, 가족을 사칭한 메시지를 받는 어른과 어르신, 그리고 이 게임을 수업이나 도서관 디지털 리터러시 프로그램에 쓰는 교사와 사서입니다. 하루 한 판은 아침 브리핑에서 오늘의 조건을 배우고, 서류를 대조하고, 판정한 뒤, 근무가 끝나면 정답과 해설을 한꺼번에 보는 순서로 진행됩니다. 실패하면 그 날을 처음부터 다시 합니다.</a:t>
+              <a:t>플레이어는 크게 세 부류입니다. 짧게 사건을 풀며 별과 등급을 모으는 어린이·청소년, 출퇴근길에 한 판씩 하는 청년·직장인, 그리고 큰 글자와 차근차근 모드로 손주와 함께 하는 어른과 어르신입니다. 하루 한 판은 아침 브리핑에서 오늘의 조건을 배우고, 서류를 대조하고, 판정한 뒤, 근무가 끝나면 정답과 해설을 한꺼번에 보는 순서로 진행됩니다. 실패하면 그 날을 처음부터 다시 합니다.</a:t>
             </a:r>
             <a:endParaRPr lang="en-US" dirty="0"/>
           </a:p>
@@ -2736,7 +2736,7 @@
                 <a:ea typeface="맑은 고딕" pitchFamily="34" charset="-122"/>
                 <a:cs typeface="맑은 고딕" pitchFamily="34" charset="-120"/>
               </a:rPr>
-              <a:t>수상한 요청을 서류로 가려내는</a:t>
+              <a:t>단서로 수상한 요청을 가려내는</a:t>
             </a:r>
             <a:endParaRPr lang="ko-KR" sz="1900" dirty="0"/>
           </a:p>
@@ -2756,7 +2756,7 @@
                 <a:ea typeface="맑은 고딕" pitchFamily="34" charset="-122"/>
                 <a:cs typeface="맑은 고딕" pitchFamily="34" charset="-120"/>
               </a:rPr>
-              <a:t>전연령 디지털 안전 퍼즐 게임</a:t>
+              <a:t>전연령 추리 퍼즐 게임</a:t>
             </a:r>
             <a:endParaRPr lang="ko-KR" sz="1900" dirty="0"/>
           </a:p>
@@ -19013,7 +19013,7 @@
                 <a:ea typeface="맑은 고딕" pitchFamily="34" charset="-122"/>
                 <a:cs typeface="맑은 고딕" pitchFamily="34" charset="-120"/>
               </a:rPr>
-              <a:t>어린이부터 어르신까지, 수업과</a:t>
+              <a:t>어린이부터 어르신까지</a:t>
             </a:r>
             <a:endParaRPr lang="ko-KR" sz="1500" dirty="0"/>
           </a:p>
@@ -19033,7 +19033,7 @@
                 <a:ea typeface="맑은 고딕" pitchFamily="34" charset="-122"/>
                 <a:cs typeface="맑은 고딕" pitchFamily="34" charset="-120"/>
               </a:rPr>
-              <a:t>도서관 프로그램에서도 써요.</a:t>
+              <a:t>가족이 함께 즐길 수 있어요.</a:t>
             </a:r>
             <a:endParaRPr lang="ko-KR" sz="1500" dirty="0"/>
           </a:p>
@@ -19721,7 +19721,7 @@
                 <a:ea typeface="Galmuri14" pitchFamily="34" charset="-122"/>
                 <a:cs typeface="Galmuri14" pitchFamily="34" charset="-120"/>
               </a:rPr>
-              <a:t>왜 필요한가요?</a:t>
+              <a:t>무엇이 재밌나요?</a:t>
             </a:r>
             <a:endParaRPr lang="ko-KR" sz="1800" dirty="0"/>
           </a:p>
@@ -19763,7 +19763,7 @@
                 <a:ea typeface="맑은 고딕" pitchFamily="34" charset="-122"/>
                 <a:cs typeface="맑은 고딕" pitchFamily="34" charset="-120"/>
               </a:rPr>
-              <a:t>강의·포스터 위주의 교육은</a:t>
+              <a:t>서류 속 작은 차이를 찾아내는</a:t>
             </a:r>
             <a:endParaRPr lang="ko-KR" sz="1500" dirty="0"/>
           </a:p>
@@ -19783,7 +19783,7 @@
                 <a:ea typeface="맑은 고딕" pitchFamily="34" charset="-122"/>
                 <a:cs typeface="맑은 고딕" pitchFamily="34" charset="-120"/>
               </a:rPr>
-              <a:t>직접 비교하고 판단해 보는</a:t>
+              <a:t>추리, 날마다 늘어나는 규칙과</a:t>
             </a:r>
             <a:endParaRPr lang="ko-KR" sz="1500" dirty="0"/>
           </a:p>
@@ -19803,7 +19803,7 @@
                 <a:ea typeface="맑은 고딕" pitchFamily="34" charset="-122"/>
                 <a:cs typeface="맑은 고딕" pitchFamily="34" charset="-120"/>
               </a:rPr>
-              <a:t>경험으로 이어지기 어려워요.</a:t>
+              <a:t>점점 교묘해지는 사건.</a:t>
             </a:r>
             <a:endParaRPr lang="ko-KR" sz="1500" dirty="0"/>
           </a:p>
@@ -21953,7 +21953,7 @@
                 <a:ea typeface="맑은 고딕" pitchFamily="34" charset="-122"/>
                 <a:cs typeface="맑은 고딕" pitchFamily="34" charset="-120"/>
               </a:rPr>
-              <a:t>→ 두 가지만 비교했어도 알아챌 수 있었는데, 이런 '비교하는 습관'을 연습할 곳이 없어요!</a:t>
+              <a:t>→ 두 가지만 비교했어도 알아챌 수 있었어요. 이 '비교해서 가려내기'를 게임으로 만들었어요!</a:t>
             </a:r>
             <a:endParaRPr lang="ko-KR" sz="1550" dirty="0"/>
           </a:p>
@@ -23142,7 +23142,7 @@
             <a:avLst/>
           </a:prstGeom>
           <a:solidFill>
-            <a:srgbClr val="F7D84A"/>
+            <a:srgbClr val="3FBF6F"/>
           </a:solidFill>
           <a:ln/>
         </p:spPr>
@@ -23286,7 +23286,7 @@
             <a:avLst/>
           </a:prstGeom>
           <a:solidFill>
-            <a:srgbClr val="F7D84A"/>
+            <a:srgbClr val="3FBF6F"/>
           </a:solidFill>
           <a:ln/>
         </p:spPr>
@@ -23404,7 +23404,7 @@
                 <a:ea typeface="Galmuri11" pitchFamily="34" charset="-122"/>
                 <a:cs typeface="Galmuri11" pitchFamily="34" charset="-120"/>
               </a:rPr>
-              <a:t>어른·어르신</a:t>
+              <a:t>청년·직장인</a:t>
             </a:r>
             <a:endParaRPr lang="ko-KR" sz="1200" dirty="0"/>
           </a:p>
@@ -23563,7 +23563,7 @@
                 <a:ea typeface="맑은 고딕" pitchFamily="34" charset="-122"/>
                 <a:cs typeface="맑은 고딕" pitchFamily="34" charset="-120"/>
               </a:rPr>
-              <a:t>“손주라는 메시지,</a:t>
+              <a:t>“택배·쇼핑 문자가</a:t>
             </a:r>
             <a:endParaRPr lang="ko-KR" sz="1400" dirty="0"/>
           </a:p>
@@ -23580,7 +23580,7 @@
                 <a:ea typeface="맑은 고딕" pitchFamily="34" charset="-122"/>
                 <a:cs typeface="맑은 고딕" pitchFamily="34" charset="-120"/>
               </a:rPr>
-              <a:t>어떻게 확인하지?”</a:t>
+              <a:t>하루에도 몇 통씩”</a:t>
             </a:r>
             <a:endParaRPr lang="ko-KR" sz="1400" dirty="0"/>
           </a:p>
@@ -23619,7 +23619,7 @@
                 <a:ea typeface="Galmuri11" pitchFamily="34" charset="-122"/>
                 <a:cs typeface="Galmuri11" pitchFamily="34" charset="-120"/>
               </a:rPr>
-              <a:t>하는 일 · 박영순(68세)</a:t>
+              <a:t>하는 일 · 하늘(27세)</a:t>
             </a:r>
             <a:endParaRPr lang="ko-KR" sz="1100" dirty="0"/>
           </a:p>
@@ -23658,7 +23658,7 @@
                 <a:ea typeface="맑은 고딕" pitchFamily="34" charset="-122"/>
                 <a:cs typeface="맑은 고딕" pitchFamily="34" charset="-120"/>
               </a:rPr>
-              <a:t>큰 글자·차근차근 모드로 손주와 함께</a:t>
+              <a:t>출퇴근길 10~15분에 하루 한 판</a:t>
             </a:r>
             <a:endParaRPr lang="ko-KR" sz="1300" dirty="0"/>
           </a:p>
@@ -23819,7 +23819,7 @@
             <a:avLst/>
           </a:prstGeom>
           <a:solidFill>
-            <a:srgbClr val="3FBF6F"/>
+            <a:srgbClr val="F7D84A"/>
           </a:solidFill>
           <a:ln/>
         </p:spPr>
@@ -23963,7 +23963,7 @@
             <a:avLst/>
           </a:prstGeom>
           <a:solidFill>
-            <a:srgbClr val="3FBF6F"/>
+            <a:srgbClr val="F7D84A"/>
           </a:solidFill>
           <a:ln/>
         </p:spPr>
@@ -24081,7 +24081,7 @@
                 <a:ea typeface="Galmuri11" pitchFamily="34" charset="-122"/>
                 <a:cs typeface="Galmuri11" pitchFamily="34" charset="-120"/>
               </a:rPr>
-              <a:t>교사·사서</a:t>
+              <a:t>어른·어르신</a:t>
             </a:r>
             <a:endParaRPr lang="ko-KR" sz="1200" dirty="0"/>
           </a:p>
@@ -24240,7 +24240,7 @@
                 <a:ea typeface="맑은 고딕" pitchFamily="34" charset="-122"/>
                 <a:cs typeface="맑은 고딕" pitchFamily="34" charset="-120"/>
               </a:rPr>
-              <a:t>“광고 없는 교육 자료가</a:t>
+              <a:t>“손주라는 메시지,</a:t>
             </a:r>
             <a:endParaRPr lang="ko-KR" sz="1400" dirty="0"/>
           </a:p>
@@ -24257,7 +24257,7 @@
                 <a:ea typeface="맑은 고딕" pitchFamily="34" charset="-122"/>
                 <a:cs typeface="맑은 고딕" pitchFamily="34" charset="-120"/>
               </a:rPr>
-              <a:t>필요해요”</a:t>
+              <a:t>어떻게 확인하지?”</a:t>
             </a:r>
             <a:endParaRPr lang="ko-KR" sz="1400" dirty="0"/>
           </a:p>
@@ -24296,7 +24296,7 @@
                 <a:ea typeface="Galmuri11" pitchFamily="34" charset="-122"/>
                 <a:cs typeface="Galmuri11" pitchFamily="34" charset="-120"/>
               </a:rPr>
-              <a:t>하는 일 · 오 사서</a:t>
+              <a:t>하는 일 · 박영순(68세)</a:t>
             </a:r>
             <a:endParaRPr lang="ko-KR" sz="1100" dirty="0"/>
           </a:p>
@@ -24335,7 +24335,7 @@
                 <a:ea typeface="맑은 고딕" pitchFamily="34" charset="-122"/>
                 <a:cs typeface="맑은 고딕" pitchFamily="34" charset="-120"/>
               </a:rPr>
-              <a:t>수업 1회에 브리핑·1~2일·해설 토론</a:t>
+              <a:t>큰 글자·차근차근 모드로 손주와 함께</a:t>
             </a:r>
             <a:endParaRPr lang="ko-KR" sz="1300" dirty="0"/>
           </a:p>
@@ -25599,7 +25599,7 @@
                 <a:ea typeface="Galmuri11" pitchFamily="34" charset="-122"/>
                 <a:cs typeface="Galmuri11" pitchFamily="34" charset="-120"/>
               </a:rPr>
-              <a:t>※ 교사·사서용 관리 화면이나 참여자 정보 수집은 만들지 않아요. 대신 활용 가이드 문서를 따로 둬요.</a:t>
+              <a:t>※ 광고·결제·가입 없이, 설치하면 인터넷 없이도 바로 플레이해요.</a:t>
             </a:r>
             <a:endParaRPr lang="ko-KR" sz="1100" dirty="0"/>
           </a:p>

</xml_diff>